<commit_message>
Fix Drop2PPT sample PowerPoint files
</commit_message>
<xml_diff>
--- a/public/assets/samples/corporate-lp-after.pptx
+++ b/public/assets/samples/corporate-lp-after.pptx
@@ -7,7 +7,7 @@
   <p:sldIdLst>
     <p:sldId id="256" r:id="rId7"/>
   </p:sldIdLst>
-  <p:sldSz cx="12192000" cy="6861645" type="screen4x3"/>
+  <p:sldSz cx="8128000" cy="12192000" type="screen4x3"/>
   <p:notesSz cx="6858000" cy="9144000"/>
   <p:defaultTextStyle>
     <a:defPPr>
@@ -3084,7 +3084,7 @@
     <p:bg>
       <p:bgPr>
         <a:solidFill>
-          <a:srgbClr val="000511"/>
+          <a:srgbClr val="F4F7FA"/>
         </a:solidFill>
         <a:effectLst/>
       </p:bgPr>
@@ -3096,16 +3096,64 @@
         <p:nvPr/>
       </p:nvGrpSpPr>
       <p:grpSpPr/>
-      <p:sp>
-        <p:nvSpPr>
-          <p:cNvPr id="2" name="TextBox 1"/>
+      <p:pic>
+        <p:nvPicPr>
+          <p:cNvPr id="2" name="Picture 1" descr="region-1.png"/>
+          <p:cNvPicPr>
+            <a:picLocks noChangeAspect="1"/>
+          </p:cNvPicPr>
+          <p:nvPr/>
+        </p:nvPicPr>
+        <p:blipFill>
+          <a:blip r:embed="rId2"/>
+          <a:stretch>
+            <a:fillRect/>
+          </a:stretch>
+        </p:blipFill>
+        <p:spPr>
+          <a:xfrm>
+            <a:off x="3901440" y="4511040"/>
+            <a:ext cx="4064000" cy="3048000"/>
+          </a:xfrm>
+          <a:prstGeom prst="rect">
+            <a:avLst/>
+          </a:prstGeom>
+        </p:spPr>
+      </p:pic>
+      <p:pic>
+        <p:nvPicPr>
+          <p:cNvPr id="3" name="Picture 2" descr="region-4.png"/>
+          <p:cNvPicPr>
+            <a:picLocks noChangeAspect="1"/>
+          </p:cNvPicPr>
+          <p:nvPr/>
+        </p:nvPicPr>
+        <p:blipFill>
+          <a:blip r:embed="rId3"/>
+          <a:stretch>
+            <a:fillRect/>
+          </a:stretch>
+        </p:blipFill>
+        <p:spPr>
+          <a:xfrm>
+            <a:off x="0" y="11460480"/>
+            <a:ext cx="8128000" cy="731520"/>
+          </a:xfrm>
+          <a:prstGeom prst="rect">
+            <a:avLst/>
+          </a:prstGeom>
+        </p:spPr>
+      </p:pic>
+      <p:sp>
+        <p:nvSpPr>
+          <p:cNvPr id="4" name="TextBox 3"/>
           <p:cNvSpPr txBox="1"/>
           <p:nvPr/>
         </p:nvSpPr>
         <p:spPr>
           <a:xfrm>
-            <a:off x="2682240" y="68616"/>
-            <a:ext cx="6827520" cy="480315"/>
+            <a:off x="162560" y="243840"/>
+            <a:ext cx="3657600" cy="609600"/>
           </a:xfrm>
           <a:prstGeom prst="rect">
             <a:avLst/>
@@ -3121,25 +3169,25 @@
             <a:r>
               <a:rPr b="1" sz="2800">
                 <a:solidFill>
-                  <a:srgbClr val="FFFFFF"/>
+                  <a:srgbClr val="0B305F"/>
                 </a:solidFill>
                 <a:latin typeface="Yu Gothic"/>
               </a:rPr>
-              <a:t>AEO処理シーケンス</a:t>
-            </a:r>
-          </a:p>
-        </p:txBody>
-      </p:sp>
-      <p:sp>
-        <p:nvSpPr>
-          <p:cNvPr id="3" name="TextBox 2"/>
+              <a:t>会社の強みを、</a:t>
+            </a:r>
+          </a:p>
+        </p:txBody>
+      </p:sp>
+      <p:sp>
+        <p:nvSpPr>
+          <p:cNvPr id="5" name="TextBox 4"/>
           <p:cNvSpPr txBox="1"/>
           <p:nvPr/>
         </p:nvSpPr>
         <p:spPr>
           <a:xfrm>
-            <a:off x="3048000" y="548931"/>
-            <a:ext cx="6096000" cy="205849"/>
+            <a:off x="162560" y="853440"/>
+            <a:ext cx="3657600" cy="609600"/>
           </a:xfrm>
           <a:prstGeom prst="rect">
             <a:avLst/>
@@ -3153,37 +3201,108 @@
           <a:lstStyle/>
           <a:p>
             <a:r>
-              <a:rPr b="1" sz="1200">
-                <a:solidFill>
-                  <a:srgbClr val="00E5FF"/>
+              <a:rPr b="1" sz="2800">
+                <a:solidFill>
+                  <a:srgbClr val="0B305F"/>
                 </a:solidFill>
                 <a:latin typeface="Yu Gothic"/>
               </a:rPr>
-              <a:t>公式HP・入力情報・デザインカンプを解析し、個別設計のLPへ分解・構築</a:t>
-            </a:r>
-          </a:p>
-        </p:txBody>
-      </p:sp>
-      <p:sp>
-        <p:nvSpPr>
-          <p:cNvPr id="4" name="Rounded Rectangle 3"/>
+              <a:t>問い合わせにつながる</a:t>
+            </a:r>
+          </a:p>
+        </p:txBody>
+      </p:sp>
+      <p:sp>
+        <p:nvSpPr>
+          <p:cNvPr id="6" name="TextBox 5"/>
+          <p:cNvSpPr txBox="1"/>
+          <p:nvPr/>
+        </p:nvSpPr>
+        <p:spPr>
+          <a:xfrm>
+            <a:off x="162560" y="1463040"/>
+            <a:ext cx="3657600" cy="731520"/>
+          </a:xfrm>
+          <a:prstGeom prst="rect">
+            <a:avLst/>
+          </a:prstGeom>
+          <a:noFill/>
+        </p:spPr>
+        <p:txBody>
+          <a:bodyPr wrap="none" lIns="0" rIns="0" tIns="0" bIns="0">
+            <a:spAutoFit/>
+          </a:bodyPr>
+          <a:lstStyle/>
+          <a:p>
+            <a:r>
+              <a:rPr b="1" sz="3600">
+                <a:solidFill>
+                  <a:srgbClr val="B89030"/>
+                </a:solidFill>
+                <a:latin typeface="Yu Gothic"/>
+              </a:rPr>
+              <a:t>AI対応LPへ。</a:t>
+            </a:r>
+          </a:p>
+        </p:txBody>
+      </p:sp>
+      <p:sp>
+        <p:nvSpPr>
+          <p:cNvPr id="7" name="TextBox 6"/>
+          <p:cNvSpPr txBox="1"/>
+          <p:nvPr/>
+        </p:nvSpPr>
+        <p:spPr>
+          <a:xfrm>
+            <a:off x="162560" y="2194560"/>
+            <a:ext cx="3413760" cy="975360"/>
+          </a:xfrm>
+          <a:prstGeom prst="rect">
+            <a:avLst/>
+          </a:prstGeom>
+          <a:noFill/>
+        </p:spPr>
+        <p:txBody>
+          <a:bodyPr wrap="none" lIns="0" rIns="0" tIns="0" bIns="0">
+            <a:spAutoFit/>
+          </a:bodyPr>
+          <a:lstStyle/>
+          <a:p>
+            <a:r>
+              <a:rPr b="0" sz="1200">
+                <a:solidFill>
+                  <a:srgbClr val="333333"/>
+                </a:solidFill>
+                <a:latin typeface="Yu Gothic"/>
+              </a:rPr>
+              <a:t>事業内容・サービス・顧客課題・強みをもとに、
+AIが専用デザインカンプを作成。
+テンプレートではなく、商談獲得を目的にした
+BtoB向けLPを個別に設計します。</a:t>
+            </a:r>
+          </a:p>
+        </p:txBody>
+      </p:sp>
+      <p:sp>
+        <p:nvSpPr>
+          <p:cNvPr id="8" name="Rounded Rectangle 7"/>
           <p:cNvSpPr/>
           <p:nvPr/>
         </p:nvSpPr>
         <p:spPr>
           <a:xfrm>
-            <a:off x="121920" y="617548"/>
-            <a:ext cx="1706880" cy="274465"/>
+            <a:off x="162560" y="3291840"/>
+            <a:ext cx="812800" cy="975360"/>
           </a:xfrm>
           <a:prstGeom prst="roundRect">
             <a:avLst/>
           </a:prstGeom>
           <a:solidFill>
-            <a:srgbClr val="001533"/>
+            <a:srgbClr val="FFFFFF"/>
           </a:solidFill>
           <a:ln w="15000">
             <a:solidFill>
-              <a:srgbClr val="00E5FF"/>
+              <a:srgbClr val="E0E0E0"/>
             </a:solidFill>
           </a:ln>
         </p:spPr>
@@ -3202,32 +3321,23 @@
           </a:fontRef>
         </p:style>
         <p:txBody>
-          <a:bodyPr rtlCol="0" anchor="ctr" lIns="70000" rIns="70000" tIns="50000" bIns="50000" wrap="square"/>
+          <a:bodyPr rtlCol="0" anchor="ctr"/>
           <a:lstStyle/>
           <a:p>
             <a:pPr algn="ctr"/>
-            <a:r>
-              <a:rPr b="1" sz="1000">
-                <a:solidFill>
-                  <a:srgbClr val="00E5FF"/>
-                </a:solidFill>
-                <a:latin typeface="Meiryo"/>
-              </a:rPr>
-              <a:t>リアルタイム処理ログ</a:t>
-            </a:r>
-          </a:p>
-        </p:txBody>
-      </p:sp>
-      <p:sp>
-        <p:nvSpPr>
-          <p:cNvPr id="5" name="TextBox 4"/>
+          </a:p>
+        </p:txBody>
+      </p:sp>
+      <p:sp>
+        <p:nvSpPr>
+          <p:cNvPr id="9" name="TextBox 8"/>
           <p:cNvSpPr txBox="1"/>
           <p:nvPr/>
         </p:nvSpPr>
         <p:spPr>
           <a:xfrm>
-            <a:off x="121920" y="960630"/>
-            <a:ext cx="1706880" cy="3293589"/>
+            <a:off x="162560" y="3779520"/>
+            <a:ext cx="812800" cy="487680"/>
           </a:xfrm>
           <a:prstGeom prst="rect">
             <a:avLst/>
@@ -3241,46 +3351,38 @@
           <a:lstStyle/>
           <a:p>
             <a:r>
-              <a:rPr b="0" sz="800">
-                <a:solidFill>
-                  <a:srgbClr val="00FF66"/>
-                </a:solidFill>
-                <a:latin typeface="Meiryo"/>
+              <a:rPr b="1" sz="1000">
+                <a:solidFill>
+                  <a:srgbClr val="333333"/>
+                </a:solidFill>
+                <a:latin typeface="Yu Gothic"/>
               </a:rPr>
-              <a:t>12 &gt; クライアント情報を受信しました
-12 &gt; 公式HPを読み込んでいます...
-12 &gt; 下層ページを調査中...
-13 &gt; FAQ構造を設計中...
-13 &gt; 強み・差別化を抽出中...
-18 &gt; 問い合わせ導線を設計中...
-19 &gt; AEO・LLMO構造化中...
-19 &gt; 画像候補を整理中...
-18 &gt; デザインカンプを生成中...
-18 &gt;</a:t>
-            </a:r>
-          </a:p>
-        </p:txBody>
-      </p:sp>
-      <p:sp>
-        <p:nvSpPr>
-          <p:cNvPr id="6" name="Rounded Rectangle 5"/>
+              <a:t>商談獲得に
+特化</a:t>
+            </a:r>
+          </a:p>
+        </p:txBody>
+      </p:sp>
+      <p:sp>
+        <p:nvSpPr>
+          <p:cNvPr id="10" name="Rounded Rectangle 9"/>
           <p:cNvSpPr/>
           <p:nvPr/>
         </p:nvSpPr>
         <p:spPr>
           <a:xfrm>
-            <a:off x="2194560" y="892013"/>
-            <a:ext cx="1584960" cy="823397"/>
+            <a:off x="1056640" y="3291840"/>
+            <a:ext cx="812800" cy="975360"/>
           </a:xfrm>
           <a:prstGeom prst="roundRect">
             <a:avLst/>
           </a:prstGeom>
           <a:solidFill>
-            <a:srgbClr val="001122"/>
+            <a:srgbClr val="FFFFFF"/>
           </a:solidFill>
           <a:ln w="15000">
             <a:solidFill>
-              <a:srgbClr val="00E5FF"/>
+              <a:srgbClr val="E0E0E0"/>
             </a:solidFill>
           </a:ln>
         </p:spPr>
@@ -3299,53 +3401,68 @@
           </a:fontRef>
         </p:style>
         <p:txBody>
-          <a:bodyPr rtlCol="0" anchor="ctr" lIns="70000" rIns="70000" tIns="50000" bIns="50000" wrap="square"/>
+          <a:bodyPr rtlCol="0" anchor="ctr"/>
           <a:lstStyle/>
           <a:p>
             <a:pPr algn="ctr"/>
-            <a:r>
-              <a:rPr b="1" sz="900">
-                <a:solidFill>
-                  <a:srgbClr val="FFFFFF"/>
+          </a:p>
+        </p:txBody>
+      </p:sp>
+      <p:sp>
+        <p:nvSpPr>
+          <p:cNvPr id="11" name="TextBox 10"/>
+          <p:cNvSpPr txBox="1"/>
+          <p:nvPr/>
+        </p:nvSpPr>
+        <p:spPr>
+          <a:xfrm>
+            <a:off x="1056640" y="3779520"/>
+            <a:ext cx="812800" cy="487680"/>
+          </a:xfrm>
+          <a:prstGeom prst="rect">
+            <a:avLst/>
+          </a:prstGeom>
+          <a:noFill/>
+        </p:spPr>
+        <p:txBody>
+          <a:bodyPr wrap="none" lIns="0" rIns="0" tIns="0" bIns="0">
+            <a:spAutoFit/>
+          </a:bodyPr>
+          <a:lstStyle/>
+          <a:p>
+            <a:r>
+              <a:rPr b="1" sz="1000">
+                <a:solidFill>
+                  <a:srgbClr val="333333"/>
                 </a:solidFill>
                 <a:latin typeface="Yu Gothic"/>
               </a:rPr>
-              <a:t>1 制作受付</a:t>
-            </a:r>
-          </a:p>
-          <a:p>
-            <a:r>
-              <a:rPr b="0" sz="700">
-                <a:solidFill>
-                  <a:srgbClr val="FFFFFF"/>
-                </a:solidFill>
-                <a:latin typeface="Yu Gothic"/>
-              </a:rPr>
-              <a:t>会社情報・公式HP参考URL・業種・問い合わせ導線を受け付ける</a:t>
-            </a:r>
-          </a:p>
-        </p:txBody>
-      </p:sp>
-      <p:sp>
-        <p:nvSpPr>
-          <p:cNvPr id="7" name="Rounded Rectangle 6"/>
+              <a:t>AI検索に
+強い構造</a:t>
+            </a:r>
+          </a:p>
+        </p:txBody>
+      </p:sp>
+      <p:sp>
+        <p:nvSpPr>
+          <p:cNvPr id="12" name="Rounded Rectangle 11"/>
           <p:cNvSpPr/>
           <p:nvPr/>
         </p:nvSpPr>
         <p:spPr>
           <a:xfrm>
-            <a:off x="3901440" y="892013"/>
-            <a:ext cx="1706880" cy="823397"/>
+            <a:off x="1950720" y="3291840"/>
+            <a:ext cx="812800" cy="975360"/>
           </a:xfrm>
           <a:prstGeom prst="roundRect">
             <a:avLst/>
           </a:prstGeom>
           <a:solidFill>
-            <a:srgbClr val="001122"/>
+            <a:srgbClr val="FFFFFF"/>
           </a:solidFill>
           <a:ln w="15000">
             <a:solidFill>
-              <a:srgbClr val="00E5FF"/>
+              <a:srgbClr val="E0E0E0"/>
             </a:solidFill>
           </a:ln>
         </p:spPr>
@@ -3364,53 +3481,68 @@
           </a:fontRef>
         </p:style>
         <p:txBody>
-          <a:bodyPr rtlCol="0" anchor="ctr" lIns="70000" rIns="70000" tIns="50000" bIns="50000" wrap="square"/>
+          <a:bodyPr rtlCol="0" anchor="ctr"/>
           <a:lstStyle/>
           <a:p>
             <a:pPr algn="ctr"/>
-            <a:r>
-              <a:rPr b="1" sz="900">
-                <a:solidFill>
-                  <a:srgbClr val="FFFFFF"/>
+          </a:p>
+        </p:txBody>
+      </p:sp>
+      <p:sp>
+        <p:nvSpPr>
+          <p:cNvPr id="13" name="TextBox 12"/>
+          <p:cNvSpPr txBox="1"/>
+          <p:nvPr/>
+        </p:nvSpPr>
+        <p:spPr>
+          <a:xfrm>
+            <a:off x="1950720" y="3779520"/>
+            <a:ext cx="812800" cy="487680"/>
+          </a:xfrm>
+          <a:prstGeom prst="rect">
+            <a:avLst/>
+          </a:prstGeom>
+          <a:noFill/>
+        </p:spPr>
+        <p:txBody>
+          <a:bodyPr wrap="none" lIns="0" rIns="0" tIns="0" bIns="0">
+            <a:spAutoFit/>
+          </a:bodyPr>
+          <a:lstStyle/>
+          <a:p>
+            <a:r>
+              <a:rPr b="1" sz="1000">
+                <a:solidFill>
+                  <a:srgbClr val="333333"/>
                 </a:solidFill>
                 <a:latin typeface="Yu Gothic"/>
               </a:rPr>
-              <a:t>2 公式HP読込</a:t>
-            </a:r>
-          </a:p>
-          <a:p>
-            <a:r>
-              <a:rPr b="0" sz="700">
-                <a:solidFill>
-                  <a:srgbClr val="FFFFFF"/>
-                </a:solidFill>
-                <a:latin typeface="Yu Gothic"/>
-              </a:rPr>
-              <a:t>公式サイトや入力URLから会社名・事業内容・サービス・電話番号・問い合わせ先を取得</a:t>
-            </a:r>
-          </a:p>
-        </p:txBody>
-      </p:sp>
-      <p:sp>
-        <p:nvSpPr>
-          <p:cNvPr id="8" name="Rounded Rectangle 7"/>
+              <a:t>事業の強みを
+最適に伝える</a:t>
+            </a:r>
+          </a:p>
+        </p:txBody>
+      </p:sp>
+      <p:sp>
+        <p:nvSpPr>
+          <p:cNvPr id="14" name="Rounded Rectangle 13"/>
           <p:cNvSpPr/>
           <p:nvPr/>
         </p:nvSpPr>
         <p:spPr>
           <a:xfrm>
-            <a:off x="5852160" y="892013"/>
-            <a:ext cx="1706880" cy="823397"/>
+            <a:off x="2844800" y="3291840"/>
+            <a:ext cx="812800" cy="975360"/>
           </a:xfrm>
           <a:prstGeom prst="roundRect">
             <a:avLst/>
           </a:prstGeom>
           <a:solidFill>
-            <a:srgbClr val="001122"/>
+            <a:srgbClr val="FFFFFF"/>
           </a:solidFill>
           <a:ln w="15000">
             <a:solidFill>
-              <a:srgbClr val="00E5FF"/>
+              <a:srgbClr val="E0E0E0"/>
             </a:solidFill>
           </a:ln>
         </p:spPr>
@@ -3429,53 +3561,68 @@
           </a:fontRef>
         </p:style>
         <p:txBody>
-          <a:bodyPr rtlCol="0" anchor="ctr" lIns="70000" rIns="70000" tIns="50000" bIns="50000" wrap="square"/>
+          <a:bodyPr rtlCol="0" anchor="ctr"/>
           <a:lstStyle/>
           <a:p>
             <a:pPr algn="ctr"/>
-            <a:r>
-              <a:rPr b="1" sz="900">
-                <a:solidFill>
-                  <a:srgbClr val="FFFFFF"/>
+          </a:p>
+        </p:txBody>
+      </p:sp>
+      <p:sp>
+        <p:nvSpPr>
+          <p:cNvPr id="15" name="TextBox 14"/>
+          <p:cNvSpPr txBox="1"/>
+          <p:nvPr/>
+        </p:nvSpPr>
+        <p:spPr>
+          <a:xfrm>
+            <a:off x="2844800" y="3779520"/>
+            <a:ext cx="812800" cy="487680"/>
+          </a:xfrm>
+          <a:prstGeom prst="rect">
+            <a:avLst/>
+          </a:prstGeom>
+          <a:noFill/>
+        </p:spPr>
+        <p:txBody>
+          <a:bodyPr wrap="none" lIns="0" rIns="0" tIns="0" bIns="0">
+            <a:spAutoFit/>
+          </a:bodyPr>
+          <a:lstStyle/>
+          <a:p>
+            <a:r>
+              <a:rPr b="1" sz="1000">
+                <a:solidFill>
+                  <a:srgbClr val="333333"/>
                 </a:solidFill>
                 <a:latin typeface="Yu Gothic"/>
               </a:rPr>
-              <a:t>3 下層ページ調査</a:t>
-            </a:r>
-          </a:p>
-          <a:p>
-            <a:r>
-              <a:rPr b="0" sz="700">
-                <a:solidFill>
-                  <a:srgbClr val="FFFFFF"/>
-                </a:solidFill>
-                <a:latin typeface="Yu Gothic"/>
-              </a:rPr>
-              <a:t>トップページだけでなくサービス・会社情報・FAQ・お知らせなど使える情報を収集</a:t>
-            </a:r>
-          </a:p>
-        </p:txBody>
-      </p:sp>
-      <p:sp>
-        <p:nvSpPr>
-          <p:cNvPr id="9" name="Rounded Rectangle 8"/>
+              <a:t>安心・安全の
+運用体制</a:t>
+            </a:r>
+          </a:p>
+        </p:txBody>
+      </p:sp>
+      <p:sp>
+        <p:nvSpPr>
+          <p:cNvPr id="16" name="Rounded Rectangle 15"/>
           <p:cNvSpPr/>
           <p:nvPr/>
         </p:nvSpPr>
         <p:spPr>
           <a:xfrm>
-            <a:off x="7680960" y="892013"/>
-            <a:ext cx="1706880" cy="823397"/>
+            <a:off x="162560" y="4511040"/>
+            <a:ext cx="3576320" cy="365760"/>
           </a:xfrm>
           <a:prstGeom prst="roundRect">
             <a:avLst/>
           </a:prstGeom>
           <a:solidFill>
-            <a:srgbClr val="001122"/>
+            <a:srgbClr val="0B305F"/>
           </a:solidFill>
           <a:ln w="15000">
             <a:solidFill>
-              <a:srgbClr val="00E5FF"/>
+              <a:srgbClr val="0B305F"/>
             </a:solidFill>
           </a:ln>
         </p:spPr>
@@ -3494,53 +3641,339 @@
           </a:fontRef>
         </p:style>
         <p:txBody>
-          <a:bodyPr rtlCol="0" anchor="ctr" lIns="70000" rIns="70000" tIns="50000" bIns="50000" wrap="square"/>
+          <a:bodyPr rtlCol="0" anchor="ctr"/>
           <a:lstStyle/>
           <a:p>
             <a:pPr algn="ctr"/>
-            <a:r>
-              <a:rPr b="1" sz="900">
+          </a:p>
+        </p:txBody>
+      </p:sp>
+      <p:sp>
+        <p:nvSpPr>
+          <p:cNvPr id="17" name="TextBox 16"/>
+          <p:cNvSpPr txBox="1"/>
+          <p:nvPr/>
+        </p:nvSpPr>
+        <p:spPr>
+          <a:xfrm>
+            <a:off x="162560" y="4511040"/>
+            <a:ext cx="3576320" cy="365760"/>
+          </a:xfrm>
+          <a:prstGeom prst="rect">
+            <a:avLst/>
+          </a:prstGeom>
+          <a:noFill/>
+        </p:spPr>
+        <p:txBody>
+          <a:bodyPr wrap="none" lIns="0" rIns="0" tIns="0" bIns="0">
+            <a:spAutoFit/>
+          </a:bodyPr>
+          <a:lstStyle/>
+          <a:p>
+            <a:r>
+              <a:rPr b="1" sz="1200">
                 <a:solidFill>
                   <a:srgbClr val="FFFFFF"/>
                 </a:solidFill>
                 <a:latin typeface="Yu Gothic"/>
               </a:rPr>
-              <a:t>4 FAQ設計</a:t>
-            </a:r>
-          </a:p>
-          <a:p>
-            <a:r>
-              <a:rPr b="0" sz="700">
-                <a:solidFill>
-                  <a:srgbClr val="FFFFFF"/>
+              <a:t>AEO＋LP 作成サービスの強み</a:t>
+            </a:r>
+          </a:p>
+        </p:txBody>
+      </p:sp>
+      <p:sp>
+        <p:nvSpPr>
+          <p:cNvPr id="18" name="TextBox 17"/>
+          <p:cNvSpPr txBox="1"/>
+          <p:nvPr/>
+        </p:nvSpPr>
+        <p:spPr>
+          <a:xfrm>
+            <a:off x="325120" y="4998720"/>
+            <a:ext cx="3251200" cy="243840"/>
+          </a:xfrm>
+          <a:prstGeom prst="rect">
+            <a:avLst/>
+          </a:prstGeom>
+          <a:noFill/>
+        </p:spPr>
+        <p:txBody>
+          <a:bodyPr wrap="none" lIns="0" rIns="0" tIns="0" bIns="0">
+            <a:spAutoFit/>
+          </a:bodyPr>
+          <a:lstStyle/>
+          <a:p>
+            <a:r>
+              <a:rPr b="1" sz="1100">
+                <a:solidFill>
+                  <a:srgbClr val="333333"/>
                 </a:solidFill>
                 <a:latin typeface="Yu Gothic"/>
               </a:rPr>
-              <a:t>問い合わせ前にユーザーが知りたい内容を整理し、AI検索に伝わりやすいFAQ構造を作る</a:t>
-            </a:r>
-          </a:p>
-        </p:txBody>
-      </p:sp>
-      <p:sp>
-        <p:nvSpPr>
-          <p:cNvPr id="10" name="Rounded Rectangle 9"/>
+              <a:t>・会社ごとに専用デザインカンプを作成</a:t>
+            </a:r>
+          </a:p>
+        </p:txBody>
+      </p:sp>
+      <p:sp>
+        <p:nvSpPr>
+          <p:cNvPr id="19" name="TextBox 18"/>
+          <p:cNvSpPr txBox="1"/>
+          <p:nvPr/>
+        </p:nvSpPr>
+        <p:spPr>
+          <a:xfrm>
+            <a:off x="325120" y="5364480"/>
+            <a:ext cx="3251200" cy="243840"/>
+          </a:xfrm>
+          <a:prstGeom prst="rect">
+            <a:avLst/>
+          </a:prstGeom>
+          <a:noFill/>
+        </p:spPr>
+        <p:txBody>
+          <a:bodyPr wrap="none" lIns="0" rIns="0" tIns="0" bIns="0">
+            <a:spAutoFit/>
+          </a:bodyPr>
+          <a:lstStyle/>
+          <a:p>
+            <a:r>
+              <a:rPr b="1" sz="1100">
+                <a:solidFill>
+                  <a:srgbClr val="333333"/>
+                </a:solidFill>
+                <a:latin typeface="Yu Gothic"/>
+              </a:rPr>
+              <a:t>・公式HPがない企業にも対応</a:t>
+            </a:r>
+          </a:p>
+        </p:txBody>
+      </p:sp>
+      <p:sp>
+        <p:nvSpPr>
+          <p:cNvPr id="20" name="TextBox 19"/>
+          <p:cNvSpPr txBox="1"/>
+          <p:nvPr/>
+        </p:nvSpPr>
+        <p:spPr>
+          <a:xfrm>
+            <a:off x="325120" y="5730240"/>
+            <a:ext cx="3251200" cy="243840"/>
+          </a:xfrm>
+          <a:prstGeom prst="rect">
+            <a:avLst/>
+          </a:prstGeom>
+          <a:noFill/>
+        </p:spPr>
+        <p:txBody>
+          <a:bodyPr wrap="none" lIns="0" rIns="0" tIns="0" bIns="0">
+            <a:spAutoFit/>
+          </a:bodyPr>
+          <a:lstStyle/>
+          <a:p>
+            <a:r>
+              <a:rPr b="1" sz="1100">
+                <a:solidFill>
+                  <a:srgbClr val="333333"/>
+                </a:solidFill>
+                <a:latin typeface="Yu Gothic"/>
+              </a:rPr>
+              <a:t>・問い合わせ・相談・資料請求フォームを標準搭載</a:t>
+            </a:r>
+          </a:p>
+        </p:txBody>
+      </p:sp>
+      <p:sp>
+        <p:nvSpPr>
+          <p:cNvPr id="21" name="TextBox 20"/>
+          <p:cNvSpPr txBox="1"/>
+          <p:nvPr/>
+        </p:nvSpPr>
+        <p:spPr>
+          <a:xfrm>
+            <a:off x="325120" y="6096000"/>
+            <a:ext cx="3251200" cy="243840"/>
+          </a:xfrm>
+          <a:prstGeom prst="rect">
+            <a:avLst/>
+          </a:prstGeom>
+          <a:noFill/>
+        </p:spPr>
+        <p:txBody>
+          <a:bodyPr wrap="none" lIns="0" rIns="0" tIns="0" bIns="0">
+            <a:spAutoFit/>
+          </a:bodyPr>
+          <a:lstStyle/>
+          <a:p>
+            <a:r>
+              <a:rPr b="1" sz="1100">
+                <a:solidFill>
+                  <a:srgbClr val="333333"/>
+                </a:solidFill>
+                <a:latin typeface="Yu Gothic"/>
+              </a:rPr>
+              <a:t>・bot対策つきで安心運用</a:t>
+            </a:r>
+          </a:p>
+        </p:txBody>
+      </p:sp>
+      <p:sp>
+        <p:nvSpPr>
+          <p:cNvPr id="22" name="TextBox 21"/>
+          <p:cNvSpPr txBox="1"/>
+          <p:nvPr/>
+        </p:nvSpPr>
+        <p:spPr>
+          <a:xfrm>
+            <a:off x="325120" y="6461760"/>
+            <a:ext cx="3251200" cy="243840"/>
+          </a:xfrm>
+          <a:prstGeom prst="rect">
+            <a:avLst/>
+          </a:prstGeom>
+          <a:noFill/>
+        </p:spPr>
+        <p:txBody>
+          <a:bodyPr wrap="none" lIns="0" rIns="0" tIns="0" bIns="0">
+            <a:spAutoFit/>
+          </a:bodyPr>
+          <a:lstStyle/>
+          <a:p>
+            <a:r>
+              <a:rPr b="1" sz="1100">
+                <a:solidFill>
+                  <a:srgbClr val="333333"/>
+                </a:solidFill>
+                <a:latin typeface="Yu Gothic"/>
+              </a:rPr>
+              <a:t>・サービス内容、導入メリット、FAQを整理</a:t>
+            </a:r>
+          </a:p>
+        </p:txBody>
+      </p:sp>
+      <p:sp>
+        <p:nvSpPr>
+          <p:cNvPr id="23" name="TextBox 22"/>
+          <p:cNvSpPr txBox="1"/>
+          <p:nvPr/>
+        </p:nvSpPr>
+        <p:spPr>
+          <a:xfrm>
+            <a:off x="325120" y="6827520"/>
+            <a:ext cx="3251200" cy="243840"/>
+          </a:xfrm>
+          <a:prstGeom prst="rect">
+            <a:avLst/>
+          </a:prstGeom>
+          <a:noFill/>
+        </p:spPr>
+        <p:txBody>
+          <a:bodyPr wrap="none" lIns="0" rIns="0" tIns="0" bIns="0">
+            <a:spAutoFit/>
+          </a:bodyPr>
+          <a:lstStyle/>
+          <a:p>
+            <a:r>
+              <a:rPr b="1" sz="1100">
+                <a:solidFill>
+                  <a:srgbClr val="333333"/>
+                </a:solidFill>
+                <a:latin typeface="Yu Gothic"/>
+              </a:rPr>
+              <a:t>・SEO / AEO / GEO / LLMO に対応</a:t>
+            </a:r>
+          </a:p>
+        </p:txBody>
+      </p:sp>
+      <p:sp>
+        <p:nvSpPr>
+          <p:cNvPr id="24" name="TextBox 23"/>
+          <p:cNvSpPr txBox="1"/>
+          <p:nvPr/>
+        </p:nvSpPr>
+        <p:spPr>
+          <a:xfrm>
+            <a:off x="325120" y="7193280"/>
+            <a:ext cx="3251200" cy="243840"/>
+          </a:xfrm>
+          <a:prstGeom prst="rect">
+            <a:avLst/>
+          </a:prstGeom>
+          <a:noFill/>
+        </p:spPr>
+        <p:txBody>
+          <a:bodyPr wrap="none" lIns="0" rIns="0" tIns="0" bIns="0">
+            <a:spAutoFit/>
+          </a:bodyPr>
+          <a:lstStyle/>
+          <a:p>
+            <a:r>
+              <a:rPr b="1" sz="1100">
+                <a:solidFill>
+                  <a:srgbClr val="333333"/>
+                </a:solidFill>
+                <a:latin typeface="Yu Gothic"/>
+              </a:rPr>
+              <a:t>・AI検索に伝わる構造化データを実装</a:t>
+            </a:r>
+          </a:p>
+        </p:txBody>
+      </p:sp>
+      <p:sp>
+        <p:nvSpPr>
+          <p:cNvPr id="25" name="TextBox 24"/>
+          <p:cNvSpPr txBox="1"/>
+          <p:nvPr/>
+        </p:nvSpPr>
+        <p:spPr>
+          <a:xfrm>
+            <a:off x="325120" y="7559040"/>
+            <a:ext cx="3251200" cy="243840"/>
+          </a:xfrm>
+          <a:prstGeom prst="rect">
+            <a:avLst/>
+          </a:prstGeom>
+          <a:noFill/>
+        </p:spPr>
+        <p:txBody>
+          <a:bodyPr wrap="none" lIns="0" rIns="0" tIns="0" bIns="0">
+            <a:spAutoFit/>
+          </a:bodyPr>
+          <a:lstStyle/>
+          <a:p>
+            <a:r>
+              <a:rPr b="1" sz="1100">
+                <a:solidFill>
+                  <a:srgbClr val="333333"/>
+                </a:solidFill>
+                <a:latin typeface="Yu Gothic"/>
+              </a:rPr>
+              <a:t>・公開後のAEO更新にも対応可能</a:t>
+            </a:r>
+          </a:p>
+        </p:txBody>
+      </p:sp>
+      <p:sp>
+        <p:nvSpPr>
+          <p:cNvPr id="26" name="Oval 25"/>
           <p:cNvSpPr/>
           <p:nvPr/>
         </p:nvSpPr>
         <p:spPr>
           <a:xfrm>
-            <a:off x="7802880" y="1852644"/>
-            <a:ext cx="1706880" cy="754780"/>
-          </a:xfrm>
-          <a:prstGeom prst="roundRect">
+            <a:off x="4064000" y="6339840"/>
+            <a:ext cx="1137920" cy="1219200"/>
+          </a:xfrm>
+          <a:prstGeom prst="ellipse">
             <a:avLst/>
           </a:prstGeom>
           <a:solidFill>
-            <a:srgbClr val="001122"/>
+            <a:srgbClr val="0B305F"/>
           </a:solidFill>
           <a:ln w="15000">
             <a:solidFill>
-              <a:srgbClr val="00E5FF"/>
+              <a:srgbClr val="0B305F"/>
             </a:solidFill>
           </a:ln>
         </p:spPr>
@@ -3559,53 +3992,69 @@
           </a:fontRef>
         </p:style>
         <p:txBody>
-          <a:bodyPr rtlCol="0" anchor="ctr" lIns="70000" rIns="70000" tIns="50000" bIns="50000" wrap="square"/>
+          <a:bodyPr rtlCol="0" anchor="ctr"/>
           <a:lstStyle/>
           <a:p>
             <a:pPr algn="ctr"/>
-            <a:r>
-              <a:rPr b="1" sz="900">
+          </a:p>
+        </p:txBody>
+      </p:sp>
+      <p:sp>
+        <p:nvSpPr>
+          <p:cNvPr id="27" name="TextBox 26"/>
+          <p:cNvSpPr txBox="1"/>
+          <p:nvPr/>
+        </p:nvSpPr>
+        <p:spPr>
+          <a:xfrm>
+            <a:off x="4064000" y="6461760"/>
+            <a:ext cx="1137920" cy="975360"/>
+          </a:xfrm>
+          <a:prstGeom prst="rect">
+            <a:avLst/>
+          </a:prstGeom>
+          <a:noFill/>
+        </p:spPr>
+        <p:txBody>
+          <a:bodyPr wrap="none" lIns="0" rIns="0" tIns="0" bIns="0">
+            <a:spAutoFit/>
+          </a:bodyPr>
+          <a:lstStyle/>
+          <a:p>
+            <a:r>
+              <a:rPr b="1" sz="1000">
                 <a:solidFill>
                   <a:srgbClr val="FFFFFF"/>
                 </a:solidFill>
                 <a:latin typeface="Yu Gothic"/>
               </a:rPr>
-              <a:t>5 強み抽出</a:t>
-            </a:r>
-          </a:p>
-          <a:p>
-            <a:r>
-              <a:rPr b="0" sz="700">
-                <a:solidFill>
-                  <a:srgbClr val="FFFFFF"/>
-                </a:solidFill>
-                <a:latin typeface="Yu Gothic"/>
-              </a:rPr>
-              <a:t>サービスの特徴・差別化・信頼材料・相談につながる要素を抽出</a:t>
-            </a:r>
-          </a:p>
-        </p:txBody>
-      </p:sp>
-      <p:sp>
-        <p:nvSpPr>
-          <p:cNvPr id="11" name="Rounded Rectangle 10"/>
+              <a:t>AI検索に
+選ばれやすい
+構造設計</a:t>
+            </a:r>
+          </a:p>
+        </p:txBody>
+      </p:sp>
+      <p:sp>
+        <p:nvSpPr>
+          <p:cNvPr id="28" name="Oval 27"/>
           <p:cNvSpPr/>
           <p:nvPr/>
         </p:nvSpPr>
         <p:spPr>
           <a:xfrm>
-            <a:off x="7802880" y="2744658"/>
-            <a:ext cx="1706880" cy="754780"/>
-          </a:xfrm>
-          <a:prstGeom prst="roundRect">
+            <a:off x="5283200" y="6339840"/>
+            <a:ext cx="1137920" cy="1219200"/>
+          </a:xfrm>
+          <a:prstGeom prst="ellipse">
             <a:avLst/>
           </a:prstGeom>
           <a:solidFill>
-            <a:srgbClr val="001122"/>
+            <a:srgbClr val="0B305F"/>
           </a:solidFill>
           <a:ln w="15000">
             <a:solidFill>
-              <a:srgbClr val="00E5FF"/>
+              <a:srgbClr val="0B305F"/>
             </a:solidFill>
           </a:ln>
         </p:spPr>
@@ -3624,53 +4073,69 @@
           </a:fontRef>
         </p:style>
         <p:txBody>
-          <a:bodyPr rtlCol="0" anchor="ctr" lIns="70000" rIns="70000" tIns="50000" bIns="50000" wrap="square"/>
+          <a:bodyPr rtlCol="0" anchor="ctr"/>
           <a:lstStyle/>
           <a:p>
             <a:pPr algn="ctr"/>
-            <a:r>
-              <a:rPr b="1" sz="900">
+          </a:p>
+        </p:txBody>
+      </p:sp>
+      <p:sp>
+        <p:nvSpPr>
+          <p:cNvPr id="29" name="TextBox 28"/>
+          <p:cNvSpPr txBox="1"/>
+          <p:nvPr/>
+        </p:nvSpPr>
+        <p:spPr>
+          <a:xfrm>
+            <a:off x="5283200" y="6461760"/>
+            <a:ext cx="1137920" cy="975360"/>
+          </a:xfrm>
+          <a:prstGeom prst="rect">
+            <a:avLst/>
+          </a:prstGeom>
+          <a:noFill/>
+        </p:spPr>
+        <p:txBody>
+          <a:bodyPr wrap="none" lIns="0" rIns="0" tIns="0" bIns="0">
+            <a:spAutoFit/>
+          </a:bodyPr>
+          <a:lstStyle/>
+          <a:p>
+            <a:r>
+              <a:rPr b="1" sz="1000">
                 <a:solidFill>
                   <a:srgbClr val="FFFFFF"/>
                 </a:solidFill>
                 <a:latin typeface="Yu Gothic"/>
               </a:rPr>
-              <a:t>6 問い合わせ導線設計</a:t>
-            </a:r>
-          </a:p>
-          <a:p>
-            <a:r>
-              <a:rPr b="0" sz="700">
-                <a:solidFill>
-                  <a:srgbClr val="FFFFFF"/>
-                </a:solidFill>
-                <a:latin typeface="Yu Gothic"/>
-              </a:rPr>
-              <a:t>電話・フォーム・予約・資料請求など、成約につながるCTA導線を設計</a:t>
-            </a:r>
-          </a:p>
-        </p:txBody>
-      </p:sp>
-      <p:sp>
-        <p:nvSpPr>
-          <p:cNvPr id="12" name="Rounded Rectangle 11"/>
+              <a:t>問い合わせに
+つながる
+導線設計</a:t>
+            </a:r>
+          </a:p>
+        </p:txBody>
+      </p:sp>
+      <p:sp>
+        <p:nvSpPr>
+          <p:cNvPr id="30" name="Oval 29"/>
           <p:cNvSpPr/>
           <p:nvPr/>
         </p:nvSpPr>
         <p:spPr>
           <a:xfrm>
-            <a:off x="7680960" y="3636671"/>
-            <a:ext cx="1828800" cy="823397"/>
-          </a:xfrm>
-          <a:prstGeom prst="roundRect">
+            <a:off x="6502400" y="6339840"/>
+            <a:ext cx="1137920" cy="1219200"/>
+          </a:xfrm>
+          <a:prstGeom prst="ellipse">
             <a:avLst/>
           </a:prstGeom>
           <a:solidFill>
-            <a:srgbClr val="001122"/>
+            <a:srgbClr val="0B305F"/>
           </a:solidFill>
           <a:ln w="15000">
             <a:solidFill>
-              <a:srgbClr val="00E5FF"/>
+              <a:srgbClr val="0B305F"/>
             </a:solidFill>
           </a:ln>
         </p:spPr>
@@ -3689,53 +4154,103 @@
           </a:fontRef>
         </p:style>
         <p:txBody>
-          <a:bodyPr rtlCol="0" anchor="ctr" lIns="70000" rIns="70000" tIns="50000" bIns="50000" wrap="square"/>
+          <a:bodyPr rtlCol="0" anchor="ctr"/>
           <a:lstStyle/>
           <a:p>
             <a:pPr algn="ctr"/>
-            <a:r>
-              <a:rPr b="1" sz="900">
+          </a:p>
+        </p:txBody>
+      </p:sp>
+      <p:sp>
+        <p:nvSpPr>
+          <p:cNvPr id="31" name="TextBox 30"/>
+          <p:cNvSpPr txBox="1"/>
+          <p:nvPr/>
+        </p:nvSpPr>
+        <p:spPr>
+          <a:xfrm>
+            <a:off x="6502400" y="6461760"/>
+            <a:ext cx="1137920" cy="975360"/>
+          </a:xfrm>
+          <a:prstGeom prst="rect">
+            <a:avLst/>
+          </a:prstGeom>
+          <a:noFill/>
+        </p:spPr>
+        <p:txBody>
+          <a:bodyPr wrap="none" lIns="0" rIns="0" tIns="0" bIns="0">
+            <a:spAutoFit/>
+          </a:bodyPr>
+          <a:lstStyle/>
+          <a:p>
+            <a:r>
+              <a:rPr b="1" sz="1000">
                 <a:solidFill>
                   <a:srgbClr val="FFFFFF"/>
                 </a:solidFill>
                 <a:latin typeface="Yu Gothic"/>
               </a:rPr>
-              <a:t>7 AEO・LLMO構造化</a:t>
-            </a:r>
-          </a:p>
-          <a:p>
-            <a:r>
-              <a:rPr b="0" sz="700">
-                <a:solidFill>
-                  <a:srgbClr val="FFFFFF"/>
+              <a:t>商談獲得を
+最大化する
+LP設計</a:t>
+            </a:r>
+          </a:p>
+        </p:txBody>
+      </p:sp>
+      <p:sp>
+        <p:nvSpPr>
+          <p:cNvPr id="32" name="TextBox 31"/>
+          <p:cNvSpPr txBox="1"/>
+          <p:nvPr/>
+        </p:nvSpPr>
+        <p:spPr>
+          <a:xfrm>
+            <a:off x="2438400" y="7680960"/>
+            <a:ext cx="3251200" cy="365760"/>
+          </a:xfrm>
+          <a:prstGeom prst="rect">
+            <a:avLst/>
+          </a:prstGeom>
+          <a:noFill/>
+        </p:spPr>
+        <p:txBody>
+          <a:bodyPr wrap="none" lIns="0" rIns="0" tIns="0" bIns="0">
+            <a:spAutoFit/>
+          </a:bodyPr>
+          <a:lstStyle/>
+          <a:p>
+            <a:r>
+              <a:rPr b="1" sz="1400">
+                <a:solidFill>
+                  <a:srgbClr val="0B305F"/>
                 </a:solidFill>
                 <a:latin typeface="Yu Gothic"/>
               </a:rPr>
-              <a:t>AI検索・生成AI回答・検索エンジンに伝わりやすい見出し・FAQ・構造化情報を整理する。</a:t>
-            </a:r>
-          </a:p>
-        </p:txBody>
-      </p:sp>
-      <p:sp>
-        <p:nvSpPr>
-          <p:cNvPr id="13" name="Rounded Rectangle 12"/>
+              <a:t>普通のホームページ制作との違い</a:t>
+            </a:r>
+          </a:p>
+        </p:txBody>
+      </p:sp>
+      <p:sp>
+        <p:nvSpPr>
+          <p:cNvPr id="33" name="Rounded Rectangle 32"/>
           <p:cNvSpPr/>
           <p:nvPr/>
         </p:nvSpPr>
         <p:spPr>
           <a:xfrm>
-            <a:off x="5730240" y="3636671"/>
-            <a:ext cx="1706880" cy="823397"/>
+            <a:off x="162560" y="7924800"/>
+            <a:ext cx="3495040" cy="365760"/>
           </a:xfrm>
           <a:prstGeom prst="roundRect">
             <a:avLst/>
           </a:prstGeom>
           <a:solidFill>
-            <a:srgbClr val="001122"/>
+            <a:srgbClr val="555555"/>
           </a:solidFill>
           <a:ln w="15000">
             <a:solidFill>
-              <a:srgbClr val="00E5FF"/>
+              <a:srgbClr val="0B305F"/>
             </a:solidFill>
           </a:ln>
         </p:spPr>
@@ -3754,53 +4269,203 @@
           </a:fontRef>
         </p:style>
         <p:txBody>
-          <a:bodyPr rtlCol="0" anchor="ctr" lIns="70000" rIns="70000" tIns="50000" bIns="50000" wrap="square"/>
+          <a:bodyPr rtlCol="0" anchor="ctr"/>
           <a:lstStyle/>
           <a:p>
             <a:pPr algn="ctr"/>
-            <a:r>
-              <a:rPr b="1" sz="900">
+          </a:p>
+        </p:txBody>
+      </p:sp>
+      <p:sp>
+        <p:nvSpPr>
+          <p:cNvPr id="34" name="TextBox 33"/>
+          <p:cNvSpPr txBox="1"/>
+          <p:nvPr/>
+        </p:nvSpPr>
+        <p:spPr>
+          <a:xfrm>
+            <a:off x="162560" y="7924800"/>
+            <a:ext cx="3495040" cy="365760"/>
+          </a:xfrm>
+          <a:prstGeom prst="rect">
+            <a:avLst/>
+          </a:prstGeom>
+          <a:noFill/>
+        </p:spPr>
+        <p:txBody>
+          <a:bodyPr wrap="none" lIns="0" rIns="0" tIns="0" bIns="0">
+            <a:spAutoFit/>
+          </a:bodyPr>
+          <a:lstStyle/>
+          <a:p>
+            <a:r>
+              <a:rPr b="1" sz="1100">
                 <a:solidFill>
                   <a:srgbClr val="FFFFFF"/>
                 </a:solidFill>
                 <a:latin typeface="Yu Gothic"/>
               </a:rPr>
-              <a:t>8 画像候補整理</a:t>
-            </a:r>
-          </a:p>
-          <a:p>
-            <a:r>
-              <a:rPr b="0" sz="700">
-                <a:solidFill>
-                  <a:srgbClr val="FFFFFF"/>
+              <a:t>一般的な制作・テンプレート</a:t>
+            </a:r>
+          </a:p>
+        </p:txBody>
+      </p:sp>
+      <p:sp>
+        <p:nvSpPr>
+          <p:cNvPr id="35" name="TextBox 34"/>
+          <p:cNvSpPr txBox="1"/>
+          <p:nvPr/>
+        </p:nvSpPr>
+        <p:spPr>
+          <a:xfrm>
+            <a:off x="1869440" y="8412480"/>
+            <a:ext cx="1625600" cy="243840"/>
+          </a:xfrm>
+          <a:prstGeom prst="rect">
+            <a:avLst/>
+          </a:prstGeom>
+          <a:noFill/>
+        </p:spPr>
+        <p:txBody>
+          <a:bodyPr wrap="none" lIns="0" rIns="0" tIns="0" bIns="0">
+            <a:spAutoFit/>
+          </a:bodyPr>
+          <a:lstStyle/>
+          <a:p>
+            <a:r>
+              <a:rPr b="0" sz="1000">
+                <a:solidFill>
+                  <a:srgbClr val="555555"/>
                 </a:solidFill>
                 <a:latin typeface="Yu Gothic"/>
               </a:rPr>
-              <a:t>ヒーロー・サービス画像・OGP画像・SNS共有画像など必要な画像の役割を決める</a:t>
-            </a:r>
-          </a:p>
-        </p:txBody>
-      </p:sp>
-      <p:sp>
-        <p:nvSpPr>
-          <p:cNvPr id="14" name="Rounded Rectangle 13"/>
+              <a:t>× 会社紹介で終わりやすい</a:t>
+            </a:r>
+          </a:p>
+        </p:txBody>
+      </p:sp>
+      <p:sp>
+        <p:nvSpPr>
+          <p:cNvPr id="36" name="TextBox 35"/>
+          <p:cNvSpPr txBox="1"/>
+          <p:nvPr/>
+        </p:nvSpPr>
+        <p:spPr>
+          <a:xfrm>
+            <a:off x="1869440" y="8656320"/>
+            <a:ext cx="1625600" cy="243840"/>
+          </a:xfrm>
+          <a:prstGeom prst="rect">
+            <a:avLst/>
+          </a:prstGeom>
+          <a:noFill/>
+        </p:spPr>
+        <p:txBody>
+          <a:bodyPr wrap="none" lIns="0" rIns="0" tIns="0" bIns="0">
+            <a:spAutoFit/>
+          </a:bodyPr>
+          <a:lstStyle/>
+          <a:p>
+            <a:r>
+              <a:rPr b="0" sz="1000">
+                <a:solidFill>
+                  <a:srgbClr val="555555"/>
+                </a:solidFill>
+                <a:latin typeface="Yu Gothic"/>
+              </a:rPr>
+              <a:t>× 問い合わせ導線が弱い</a:t>
+            </a:r>
+          </a:p>
+        </p:txBody>
+      </p:sp>
+      <p:sp>
+        <p:nvSpPr>
+          <p:cNvPr id="37" name="TextBox 36"/>
+          <p:cNvSpPr txBox="1"/>
+          <p:nvPr/>
+        </p:nvSpPr>
+        <p:spPr>
+          <a:xfrm>
+            <a:off x="1869440" y="8900160"/>
+            <a:ext cx="1625600" cy="243840"/>
+          </a:xfrm>
+          <a:prstGeom prst="rect">
+            <a:avLst/>
+          </a:prstGeom>
+          <a:noFill/>
+        </p:spPr>
+        <p:txBody>
+          <a:bodyPr wrap="none" lIns="0" rIns="0" tIns="0" bIns="0">
+            <a:spAutoFit/>
+          </a:bodyPr>
+          <a:lstStyle/>
+          <a:p>
+            <a:r>
+              <a:rPr b="0" sz="1000">
+                <a:solidFill>
+                  <a:srgbClr val="555555"/>
+                </a:solidFill>
+                <a:latin typeface="Yu Gothic"/>
+              </a:rPr>
+              <a:t>× AI検索に伝わる構造が不足</a:t>
+            </a:r>
+          </a:p>
+        </p:txBody>
+      </p:sp>
+      <p:sp>
+        <p:nvSpPr>
+          <p:cNvPr id="38" name="TextBox 37"/>
+          <p:cNvSpPr txBox="1"/>
+          <p:nvPr/>
+        </p:nvSpPr>
+        <p:spPr>
+          <a:xfrm>
+            <a:off x="1869440" y="9144000"/>
+            <a:ext cx="1625600" cy="243840"/>
+          </a:xfrm>
+          <a:prstGeom prst="rect">
+            <a:avLst/>
+          </a:prstGeom>
+          <a:noFill/>
+        </p:spPr>
+        <p:txBody>
+          <a:bodyPr wrap="none" lIns="0" rIns="0" tIns="0" bIns="0">
+            <a:spAutoFit/>
+          </a:bodyPr>
+          <a:lstStyle/>
+          <a:p>
+            <a:r>
+              <a:rPr b="0" sz="1000">
+                <a:solidFill>
+                  <a:srgbClr val="555555"/>
+                </a:solidFill>
+                <a:latin typeface="Yu Gothic"/>
+              </a:rPr>
+              <a:t>× 強みが整理されにくい</a:t>
+            </a:r>
+          </a:p>
+        </p:txBody>
+      </p:sp>
+      <p:sp>
+        <p:nvSpPr>
+          <p:cNvPr id="39" name="Rounded Rectangle 38"/>
           <p:cNvSpPr/>
           <p:nvPr/>
         </p:nvSpPr>
         <p:spPr>
           <a:xfrm>
-            <a:off x="3779520" y="3636671"/>
-            <a:ext cx="1828800" cy="823397"/>
+            <a:off x="3901440" y="7924800"/>
+            <a:ext cx="3901440" cy="365760"/>
           </a:xfrm>
           <a:prstGeom prst="roundRect">
             <a:avLst/>
           </a:prstGeom>
           <a:solidFill>
-            <a:srgbClr val="001122"/>
+            <a:srgbClr val="0B305F"/>
           </a:solidFill>
           <a:ln w="15000">
             <a:solidFill>
-              <a:srgbClr val="00E5FF"/>
+              <a:srgbClr val="0B305F"/>
             </a:solidFill>
           </a:ln>
         </p:spPr>
@@ -3819,64 +4484,203 @@
           </a:fontRef>
         </p:style>
         <p:txBody>
-          <a:bodyPr rtlCol="0" anchor="ctr" lIns="70000" rIns="70000" tIns="50000" bIns="50000" wrap="square"/>
+          <a:bodyPr rtlCol="0" anchor="ctr"/>
           <a:lstStyle/>
           <a:p>
             <a:pPr algn="ctr"/>
-            <a:r>
-              <a:rPr b="1" sz="900">
+          </a:p>
+        </p:txBody>
+      </p:sp>
+      <p:sp>
+        <p:nvSpPr>
+          <p:cNvPr id="40" name="TextBox 39"/>
+          <p:cNvSpPr txBox="1"/>
+          <p:nvPr/>
+        </p:nvSpPr>
+        <p:spPr>
+          <a:xfrm>
+            <a:off x="3901440" y="7924800"/>
+            <a:ext cx="3901440" cy="365760"/>
+          </a:xfrm>
+          <a:prstGeom prst="rect">
+            <a:avLst/>
+          </a:prstGeom>
+          <a:noFill/>
+        </p:spPr>
+        <p:txBody>
+          <a:bodyPr wrap="none" lIns="0" rIns="0" tIns="0" bIns="0">
+            <a:spAutoFit/>
+          </a:bodyPr>
+          <a:lstStyle/>
+          <a:p>
+            <a:r>
+              <a:rPr b="1" sz="1100">
                 <a:solidFill>
                   <a:srgbClr val="FFFFFF"/>
                 </a:solidFill>
                 <a:latin typeface="Yu Gothic"/>
               </a:rPr>
-              <a:t>9 デザインカンプ生成</a:t>
-            </a:r>
-          </a:p>
-          <a:p>
-            <a:r>
-              <a:rPr b="0" sz="700">
-                <a:solidFill>
-                  <a:srgbClr val="FFFFFF"/>
+              <a:t>AEO＋LP</a:t>
+            </a:r>
+          </a:p>
+        </p:txBody>
+      </p:sp>
+      <p:sp>
+        <p:nvSpPr>
+          <p:cNvPr id="41" name="TextBox 40"/>
+          <p:cNvSpPr txBox="1"/>
+          <p:nvPr/>
+        </p:nvSpPr>
+        <p:spPr>
+          <a:xfrm>
+            <a:off x="4064000" y="8412480"/>
+            <a:ext cx="2032000" cy="243840"/>
+          </a:xfrm>
+          <a:prstGeom prst="rect">
+            <a:avLst/>
+          </a:prstGeom>
+          <a:noFill/>
+        </p:spPr>
+        <p:txBody>
+          <a:bodyPr wrap="none" lIns="0" rIns="0" tIns="0" bIns="0">
+            <a:spAutoFit/>
+          </a:bodyPr>
+          <a:lstStyle/>
+          <a:p>
+            <a:r>
+              <a:rPr b="1" sz="1000">
+                <a:solidFill>
+                  <a:srgbClr val="0B305F"/>
                 </a:solidFill>
                 <a:latin typeface="Yu Gothic"/>
               </a:rPr>
-              <a:t>業種・目的に合わせた複数のデザインカンプをAI画像として生成</a:t>
-            </a:r>
-          </a:p>
-          <a:p>
-            <a:r>
-              <a:rPr b="0" sz="700">
-                <a:solidFill>
-                  <a:srgbClr val="FFFFFF"/>
+              <a:t>✓ AIが事業ごとにデザイン提案</a:t>
+            </a:r>
+          </a:p>
+        </p:txBody>
+      </p:sp>
+      <p:sp>
+        <p:nvSpPr>
+          <p:cNvPr id="42" name="TextBox 41"/>
+          <p:cNvSpPr txBox="1"/>
+          <p:nvPr/>
+        </p:nvSpPr>
+        <p:spPr>
+          <a:xfrm>
+            <a:off x="4064000" y="8656320"/>
+            <a:ext cx="2032000" cy="243840"/>
+          </a:xfrm>
+          <a:prstGeom prst="rect">
+            <a:avLst/>
+          </a:prstGeom>
+          <a:noFill/>
+        </p:spPr>
+        <p:txBody>
+          <a:bodyPr wrap="none" lIns="0" rIns="0" tIns="0" bIns="0">
+            <a:spAutoFit/>
+          </a:bodyPr>
+          <a:lstStyle/>
+          <a:p>
+            <a:r>
+              <a:rPr b="1" sz="1000">
+                <a:solidFill>
+                  <a:srgbClr val="0B305F"/>
                 </a:solidFill>
                 <a:latin typeface="Yu Gothic"/>
               </a:rPr>
-              <a:t>A案・B案・C案・D案</a:t>
-            </a:r>
-          </a:p>
-        </p:txBody>
-      </p:sp>
-      <p:sp>
-        <p:nvSpPr>
-          <p:cNvPr id="15" name="Rounded Rectangle 14"/>
+              <a:t>✓ 問い合わせと相談をLP内で受付</a:t>
+            </a:r>
+          </a:p>
+        </p:txBody>
+      </p:sp>
+      <p:sp>
+        <p:nvSpPr>
+          <p:cNvPr id="43" name="TextBox 42"/>
+          <p:cNvSpPr txBox="1"/>
+          <p:nvPr/>
+        </p:nvSpPr>
+        <p:spPr>
+          <a:xfrm>
+            <a:off x="4064000" y="8900160"/>
+            <a:ext cx="2032000" cy="243840"/>
+          </a:xfrm>
+          <a:prstGeom prst="rect">
+            <a:avLst/>
+          </a:prstGeom>
+          <a:noFill/>
+        </p:spPr>
+        <p:txBody>
+          <a:bodyPr wrap="none" lIns="0" rIns="0" tIns="0" bIns="0">
+            <a:spAutoFit/>
+          </a:bodyPr>
+          <a:lstStyle/>
+          <a:p>
+            <a:r>
+              <a:rPr b="1" sz="1000">
+                <a:solidFill>
+                  <a:srgbClr val="0B305F"/>
+                </a:solidFill>
+                <a:latin typeface="Yu Gothic"/>
+              </a:rPr>
+              <a:t>✓ FAQと構造化データでAI検索に対応</a:t>
+            </a:r>
+          </a:p>
+        </p:txBody>
+      </p:sp>
+      <p:sp>
+        <p:nvSpPr>
+          <p:cNvPr id="44" name="TextBox 43"/>
+          <p:cNvSpPr txBox="1"/>
+          <p:nvPr/>
+        </p:nvSpPr>
+        <p:spPr>
+          <a:xfrm>
+            <a:off x="4064000" y="9144000"/>
+            <a:ext cx="2032000" cy="243840"/>
+          </a:xfrm>
+          <a:prstGeom prst="rect">
+            <a:avLst/>
+          </a:prstGeom>
+          <a:noFill/>
+        </p:spPr>
+        <p:txBody>
+          <a:bodyPr wrap="none" lIns="0" rIns="0" tIns="0" bIns="0">
+            <a:spAutoFit/>
+          </a:bodyPr>
+          <a:lstStyle/>
+          <a:p>
+            <a:r>
+              <a:rPr b="1" sz="1000">
+                <a:solidFill>
+                  <a:srgbClr val="0B305F"/>
+                </a:solidFill>
+                <a:latin typeface="Yu Gothic"/>
+              </a:rPr>
+              <a:t>✓ 強み、サービス、顧客課題を営業導線に変換</a:t>
+            </a:r>
+          </a:p>
+        </p:txBody>
+      </p:sp>
+      <p:sp>
+        <p:nvSpPr>
+          <p:cNvPr id="45" name="Rectangle 44"/>
           <p:cNvSpPr/>
           <p:nvPr/>
         </p:nvSpPr>
         <p:spPr>
           <a:xfrm>
-            <a:off x="1950720" y="3568055"/>
-            <a:ext cx="1706880" cy="892013"/>
-          </a:xfrm>
-          <a:prstGeom prst="roundRect">
+            <a:off x="162560" y="9875520"/>
+            <a:ext cx="7802880" cy="609600"/>
+          </a:xfrm>
+          <a:prstGeom prst="rect">
             <a:avLst/>
           </a:prstGeom>
           <a:solidFill>
-            <a:srgbClr val="001122"/>
+            <a:srgbClr val="0B305F"/>
           </a:solidFill>
           <a:ln w="15000">
             <a:solidFill>
-              <a:srgbClr val="00E5FF"/>
+              <a:srgbClr val="0B305F"/>
             </a:solidFill>
           </a:ln>
         </p:spPr>
@@ -3895,10 +4699,35 @@
           </a:fontRef>
         </p:style>
         <p:txBody>
-          <a:bodyPr rtlCol="0" anchor="ctr" lIns="70000" rIns="70000" tIns="50000" bIns="50000" wrap="square"/>
+          <a:bodyPr rtlCol="0" anchor="ctr"/>
           <a:lstStyle/>
           <a:p>
             <a:pPr algn="ctr"/>
+          </a:p>
+        </p:txBody>
+      </p:sp>
+      <p:sp>
+        <p:nvSpPr>
+          <p:cNvPr id="46" name="TextBox 45"/>
+          <p:cNvSpPr txBox="1"/>
+          <p:nvPr/>
+        </p:nvSpPr>
+        <p:spPr>
+          <a:xfrm>
+            <a:off x="812800" y="9997440"/>
+            <a:ext cx="1219200" cy="365760"/>
+          </a:xfrm>
+          <a:prstGeom prst="rect">
+            <a:avLst/>
+          </a:prstGeom>
+          <a:noFill/>
+        </p:spPr>
+        <p:txBody>
+          <a:bodyPr wrap="none" lIns="0" rIns="0" tIns="0" bIns="0">
+            <a:spAutoFit/>
+          </a:bodyPr>
+          <a:lstStyle/>
+          <a:p>
             <a:r>
               <a:rPr b="1" sz="900">
                 <a:solidFill>
@@ -3906,42 +4735,172 @@
                 </a:solidFill>
                 <a:latin typeface="Yu Gothic"/>
               </a:rPr>
-              <a:t>10 カンプ解析</a:t>
-            </a:r>
-          </a:p>
-          <a:p>
-            <a:r>
-              <a:rPr b="0" sz="700">
+              <a:t>BtoBに最適化した
+LP設計</a:t>
+            </a:r>
+          </a:p>
+        </p:txBody>
+      </p:sp>
+      <p:sp>
+        <p:nvSpPr>
+          <p:cNvPr id="47" name="TextBox 46"/>
+          <p:cNvSpPr txBox="1"/>
+          <p:nvPr/>
+        </p:nvSpPr>
+        <p:spPr>
+          <a:xfrm>
+            <a:off x="2763520" y="9997440"/>
+            <a:ext cx="1219200" cy="365760"/>
+          </a:xfrm>
+          <a:prstGeom prst="rect">
+            <a:avLst/>
+          </a:prstGeom>
+          <a:noFill/>
+        </p:spPr>
+        <p:txBody>
+          <a:bodyPr wrap="none" lIns="0" rIns="0" tIns="0" bIns="0">
+            <a:spAutoFit/>
+          </a:bodyPr>
+          <a:lstStyle/>
+          <a:p>
+            <a:r>
+              <a:rPr b="1" sz="900">
                 <a:solidFill>
                   <a:srgbClr val="FFFFFF"/>
                 </a:solidFill>
                 <a:latin typeface="Yu Gothic"/>
               </a:rPr>
-              <a:t>生成したカンプ画像を解析し、ヒーロー・サービスカード・導入フロー・FAQ・CTAなどの意味を読み取る。</a:t>
-            </a:r>
-          </a:p>
-        </p:txBody>
-      </p:sp>
-      <p:sp>
-        <p:nvSpPr>
-          <p:cNvPr id="16" name="Rounded Rectangle 15"/>
+              <a:t>AI検索を意識した
+情報設計</a:t>
+            </a:r>
+          </a:p>
+        </p:txBody>
+      </p:sp>
+      <p:sp>
+        <p:nvSpPr>
+          <p:cNvPr id="48" name="TextBox 47"/>
+          <p:cNvSpPr txBox="1"/>
+          <p:nvPr/>
+        </p:nvSpPr>
+        <p:spPr>
+          <a:xfrm>
+            <a:off x="4714240" y="9997440"/>
+            <a:ext cx="1219200" cy="365760"/>
+          </a:xfrm>
+          <a:prstGeom prst="rect">
+            <a:avLst/>
+          </a:prstGeom>
+          <a:noFill/>
+        </p:spPr>
+        <p:txBody>
+          <a:bodyPr wrap="none" lIns="0" rIns="0" tIns="0" bIns="0">
+            <a:spAutoFit/>
+          </a:bodyPr>
+          <a:lstStyle/>
+          <a:p>
+            <a:r>
+              <a:rPr b="1" sz="900">
+                <a:solidFill>
+                  <a:srgbClr val="FFFFFF"/>
+                </a:solidFill>
+                <a:latin typeface="Yu Gothic"/>
+              </a:rPr>
+              <a:t>データに基づく
+改善提案</a:t>
+            </a:r>
+          </a:p>
+        </p:txBody>
+      </p:sp>
+      <p:sp>
+        <p:nvSpPr>
+          <p:cNvPr id="49" name="TextBox 48"/>
+          <p:cNvSpPr txBox="1"/>
+          <p:nvPr/>
+        </p:nvSpPr>
+        <p:spPr>
+          <a:xfrm>
+            <a:off x="6502400" y="9997440"/>
+            <a:ext cx="1463040" cy="365760"/>
+          </a:xfrm>
+          <a:prstGeom prst="rect">
+            <a:avLst/>
+          </a:prstGeom>
+          <a:noFill/>
+        </p:spPr>
+        <p:txBody>
+          <a:bodyPr wrap="none" lIns="0" rIns="0" tIns="0" bIns="0">
+            <a:spAutoFit/>
+          </a:bodyPr>
+          <a:lstStyle/>
+          <a:p>
+            <a:r>
+              <a:rPr b="1" sz="900">
+                <a:solidFill>
+                  <a:srgbClr val="FFFFFF"/>
+                </a:solidFill>
+                <a:latin typeface="Yu Gothic"/>
+              </a:rPr>
+              <a:t>公開後の運用・改善まで
+継続サポート</a:t>
+            </a:r>
+          </a:p>
+        </p:txBody>
+      </p:sp>
+      <p:sp>
+        <p:nvSpPr>
+          <p:cNvPr id="50" name="TextBox 49"/>
+          <p:cNvSpPr txBox="1"/>
+          <p:nvPr/>
+        </p:nvSpPr>
+        <p:spPr>
+          <a:xfrm>
+            <a:off x="406400" y="10607040"/>
+            <a:ext cx="3657600" cy="731520"/>
+          </a:xfrm>
+          <a:prstGeom prst="rect">
+            <a:avLst/>
+          </a:prstGeom>
+          <a:noFill/>
+        </p:spPr>
+        <p:txBody>
+          <a:bodyPr wrap="none" lIns="0" rIns="0" tIns="0" bIns="0">
+            <a:spAutoFit/>
+          </a:bodyPr>
+          <a:lstStyle/>
+          <a:p>
+            <a:r>
+              <a:rPr b="1" sz="1800">
+                <a:solidFill>
+                  <a:srgbClr val="0B305F"/>
+                </a:solidFill>
+                <a:latin typeface="Yu Gothic"/>
+              </a:rPr>
+              <a:t>まずは事業内容から、
+専用LPをご提案します。</a:t>
+            </a:r>
+          </a:p>
+        </p:txBody>
+      </p:sp>
+      <p:sp>
+        <p:nvSpPr>
+          <p:cNvPr id="51" name="Rounded Rectangle 50"/>
           <p:cNvSpPr/>
           <p:nvPr/>
         </p:nvSpPr>
         <p:spPr>
           <a:xfrm>
-            <a:off x="1950720" y="2744658"/>
-            <a:ext cx="1706880" cy="754780"/>
+            <a:off x="4307840" y="10607040"/>
+            <a:ext cx="3413760" cy="609600"/>
           </a:xfrm>
           <a:prstGeom prst="roundRect">
             <a:avLst/>
           </a:prstGeom>
           <a:solidFill>
-            <a:srgbClr val="001122"/>
+            <a:srgbClr val="B89030"/>
           </a:solidFill>
           <a:ln w="15000">
             <a:solidFill>
-              <a:srgbClr val="00E5FF"/>
+              <a:srgbClr val="0B305F"/>
             </a:solidFill>
           </a:ln>
         </p:spPr>
@@ -3960,108 +4919,23 @@
           </a:fontRef>
         </p:style>
         <p:txBody>
-          <a:bodyPr rtlCol="0" anchor="ctr" lIns="70000" rIns="70000" tIns="50000" bIns="50000" wrap="square"/>
+          <a:bodyPr rtlCol="0" anchor="ctr"/>
           <a:lstStyle/>
           <a:p>
             <a:pPr algn="ctr"/>
-            <a:r>
-              <a:rPr b="1" sz="900">
-                <a:solidFill>
-                  <a:srgbClr val="FFFFFF"/>
-                </a:solidFill>
-                <a:latin typeface="Yu Gothic"/>
-              </a:rPr>
-              <a:t>11 HTML分解</a:t>
-            </a:r>
-          </a:p>
-          <a:p>
-            <a:r>
-              <a:rPr b="0" sz="700">
-                <a:solidFill>
-                  <a:srgbClr val="FFFFFF"/>
-                </a:solidFill>
-                <a:latin typeface="Yu Gothic"/>
-              </a:rPr>
-              <a:t>カンプ画像をそのまま貼らず、各ブロックをHTML・文章・リンク・ボタンとして再構築する。</a:t>
-            </a:r>
-          </a:p>
-        </p:txBody>
-      </p:sp>
-      <p:sp>
-        <p:nvSpPr>
-          <p:cNvPr id="17" name="Rounded Rectangle 16"/>
-          <p:cNvSpPr/>
-          <p:nvPr/>
-        </p:nvSpPr>
-        <p:spPr>
-          <a:xfrm>
-            <a:off x="1950720" y="1784027"/>
-            <a:ext cx="1706880" cy="892013"/>
-          </a:xfrm>
-          <a:prstGeom prst="roundRect">
-            <a:avLst/>
-          </a:prstGeom>
-          <a:solidFill>
-            <a:srgbClr val="001122"/>
-          </a:solidFill>
-          <a:ln w="15000">
-            <a:solidFill>
-              <a:srgbClr val="00E5FF"/>
-            </a:solidFill>
-          </a:ln>
-        </p:spPr>
-        <p:style>
-          <a:lnRef idx="1">
-            <a:schemeClr val="accent1"/>
-          </a:lnRef>
-          <a:fillRef idx="3">
-            <a:schemeClr val="accent1"/>
-          </a:fillRef>
-          <a:effectRef idx="2">
-            <a:schemeClr val="accent1"/>
-          </a:effectRef>
-          <a:fontRef idx="minor">
-            <a:schemeClr val="lt1"/>
-          </a:fontRef>
-        </p:style>
-        <p:txBody>
-          <a:bodyPr rtlCol="0" anchor="ctr" lIns="70000" rIns="70000" tIns="50000" bIns="50000" wrap="square"/>
-          <a:lstStyle/>
-          <a:p>
-            <a:pPr algn="ctr"/>
-            <a:r>
-              <a:rPr b="1" sz="900">
-                <a:solidFill>
-                  <a:srgbClr val="FFFFFF"/>
-                </a:solidFill>
-                <a:latin typeface="Yu Gothic"/>
-              </a:rPr>
-              <a:t>12 LP仕上げ</a:t>
-            </a:r>
-          </a:p>
-          <a:p>
-            <a:r>
-              <a:rPr b="0" sz="700">
-                <a:solidFill>
-                  <a:srgbClr val="FFFFFF"/>
-                </a:solidFill>
-                <a:latin typeface="Yu Gothic"/>
-              </a:rPr>
-              <a:t>スマホ表示・問い合わせ導線・独立ページ・OGP・最終確認を行い、ユーザー専用LPとして仕上げる。</a:t>
-            </a:r>
-          </a:p>
-        </p:txBody>
-      </p:sp>
-      <p:sp>
-        <p:nvSpPr>
-          <p:cNvPr id="18" name="TextBox 17"/>
+          </a:p>
+        </p:txBody>
+      </p:sp>
+      <p:sp>
+        <p:nvSpPr>
+          <p:cNvPr id="52" name="TextBox 51"/>
           <p:cNvSpPr txBox="1"/>
           <p:nvPr/>
         </p:nvSpPr>
         <p:spPr>
           <a:xfrm>
-            <a:off x="10119360" y="137232"/>
-            <a:ext cx="1706880" cy="274465"/>
+            <a:off x="4307840" y="10728960"/>
+            <a:ext cx="3413760" cy="365760"/>
           </a:xfrm>
           <a:prstGeom prst="rect">
             <a:avLst/>
@@ -4081,21 +4955,21 @@
                 </a:solidFill>
                 <a:latin typeface="Yu Gothic"/>
               </a:rPr>
-              <a:t>処理ステータス</a:t>
-            </a:r>
-          </a:p>
-        </p:txBody>
-      </p:sp>
-      <p:sp>
-        <p:nvSpPr>
-          <p:cNvPr id="19" name="TextBox 18"/>
+              <a:t>お問い合わせ・ご相談はこちら</a:t>
+            </a:r>
+          </a:p>
+        </p:txBody>
+      </p:sp>
+      <p:sp>
+        <p:nvSpPr>
+          <p:cNvPr id="53" name="TextBox 52"/>
           <p:cNvSpPr txBox="1"/>
           <p:nvPr/>
         </p:nvSpPr>
         <p:spPr>
           <a:xfrm>
-            <a:off x="10119360" y="548931"/>
-            <a:ext cx="1706880" cy="274465"/>
+            <a:off x="4307840" y="11216640"/>
+            <a:ext cx="3413760" cy="243840"/>
           </a:xfrm>
           <a:prstGeom prst="rect">
             <a:avLst/>
@@ -4109,1025 +4983,20 @@
           <a:lstStyle/>
           <a:p>
             <a:r>
-              <a:rPr b="1" sz="1800">
+              <a:rPr b="0" sz="900">
                 <a:solidFill>
                   <a:srgbClr val="FFFFFF"/>
-                </a:solidFill>
-                <a:latin typeface="Aptos"/>
-              </a:rPr>
-              <a:t>Stage 10 / 12</a:t>
-            </a:r>
-          </a:p>
-        </p:txBody>
-      </p:sp>
-      <p:sp>
-        <p:nvSpPr>
-          <p:cNvPr id="20" name="TextBox 19"/>
-          <p:cNvSpPr txBox="1"/>
-          <p:nvPr/>
-        </p:nvSpPr>
-        <p:spPr>
-          <a:xfrm>
-            <a:off x="10119360" y="892013"/>
-            <a:ext cx="1706880" cy="205849"/>
-          </a:xfrm>
-          <a:prstGeom prst="rect">
-            <a:avLst/>
-          </a:prstGeom>
-          <a:noFill/>
-        </p:spPr>
-        <p:txBody>
-          <a:bodyPr wrap="none" lIns="0" rIns="0" tIns="0" bIns="0">
-            <a:spAutoFit/>
-          </a:bodyPr>
-          <a:lstStyle/>
-          <a:p>
-            <a:r>
-              <a:rPr b="1" sz="1400">
-                <a:solidFill>
-                  <a:srgbClr val="00E5FF"/>
                 </a:solidFill>
                 <a:latin typeface="Yu Gothic"/>
               </a:rPr>
-              <a:t>カンプ解析中</a:t>
-            </a:r>
-          </a:p>
-        </p:txBody>
-      </p:sp>
-      <p:sp>
-        <p:nvSpPr>
-          <p:cNvPr id="21" name="TextBox 20"/>
-          <p:cNvSpPr txBox="1"/>
-          <p:nvPr/>
-        </p:nvSpPr>
-        <p:spPr>
-          <a:xfrm>
-            <a:off x="10607040" y="1509561"/>
-            <a:ext cx="731520" cy="343082"/>
-          </a:xfrm>
-          <a:prstGeom prst="rect">
-            <a:avLst/>
-          </a:prstGeom>
-          <a:noFill/>
-        </p:spPr>
-        <p:txBody>
-          <a:bodyPr wrap="none" lIns="0" rIns="0" tIns="0" bIns="0">
-            <a:spAutoFit/>
-          </a:bodyPr>
-          <a:lstStyle/>
-          <a:p>
-            <a:r>
-              <a:rPr b="1" sz="2200">
-                <a:solidFill>
-                  <a:srgbClr val="FFFFFF"/>
-                </a:solidFill>
-                <a:latin typeface="Aptos"/>
-              </a:rPr>
-              <a:t>87%</a:t>
-            </a:r>
-          </a:p>
-        </p:txBody>
-      </p:sp>
-      <p:sp>
-        <p:nvSpPr>
-          <p:cNvPr id="22" name="TextBox 21"/>
-          <p:cNvSpPr txBox="1"/>
-          <p:nvPr/>
-        </p:nvSpPr>
-        <p:spPr>
-          <a:xfrm>
-            <a:off x="9997440" y="2264342"/>
-            <a:ext cx="731520" cy="137232"/>
-          </a:xfrm>
-          <a:prstGeom prst="rect">
-            <a:avLst/>
-          </a:prstGeom>
-          <a:noFill/>
-        </p:spPr>
-        <p:txBody>
-          <a:bodyPr wrap="none" lIns="0" rIns="0" tIns="0" bIns="0">
-            <a:spAutoFit/>
-          </a:bodyPr>
-          <a:lstStyle/>
-          <a:p>
-            <a:r>
-              <a:rPr b="0" sz="900">
-                <a:solidFill>
-                  <a:srgbClr val="FFFFFF"/>
-                </a:solidFill>
-                <a:latin typeface="Yu Gothic"/>
-              </a:rPr>
-              <a:t>進行状況</a:t>
-            </a:r>
-          </a:p>
-        </p:txBody>
-      </p:sp>
-      <p:sp>
-        <p:nvSpPr>
-          <p:cNvPr id="23" name="TextBox 22"/>
-          <p:cNvSpPr txBox="1"/>
-          <p:nvPr/>
-        </p:nvSpPr>
-        <p:spPr>
-          <a:xfrm>
-            <a:off x="9997440" y="2676041"/>
-            <a:ext cx="1828800" cy="137232"/>
-          </a:xfrm>
-          <a:prstGeom prst="rect">
-            <a:avLst/>
-          </a:prstGeom>
-          <a:noFill/>
-        </p:spPr>
-        <p:txBody>
-          <a:bodyPr wrap="none" lIns="0" rIns="0" tIns="0" bIns="0">
-            <a:spAutoFit/>
-          </a:bodyPr>
-          <a:lstStyle/>
-          <a:p>
-            <a:r>
-              <a:rPr b="1" sz="1000">
-                <a:solidFill>
-                  <a:srgbClr val="00E5FF"/>
-                </a:solidFill>
-                <a:latin typeface="Yu Gothic"/>
-              </a:rPr>
-              <a:t>現在の処理</a:t>
-            </a:r>
-          </a:p>
-        </p:txBody>
-      </p:sp>
-      <p:sp>
-        <p:nvSpPr>
-          <p:cNvPr id="24" name="TextBox 23"/>
-          <p:cNvSpPr txBox="1"/>
-          <p:nvPr/>
-        </p:nvSpPr>
-        <p:spPr>
-          <a:xfrm>
-            <a:off x="9997440" y="2881890"/>
-            <a:ext cx="1950720" cy="617548"/>
-          </a:xfrm>
-          <a:prstGeom prst="rect">
-            <a:avLst/>
-          </a:prstGeom>
-          <a:noFill/>
-        </p:spPr>
-        <p:txBody>
-          <a:bodyPr wrap="none" lIns="0" rIns="0" tIns="0" bIns="0">
-            <a:spAutoFit/>
-          </a:bodyPr>
-          <a:lstStyle/>
-          <a:p>
-            <a:r>
-              <a:rPr b="0" sz="900">
-                <a:solidFill>
-                  <a:srgbClr val="FFFFFF"/>
-                </a:solidFill>
-                <a:latin typeface="Yu Gothic"/>
-              </a:rPr>
-              <a:t>・カンプ画像を解析中...
-・ヒーロー・サービスカードを抽出
-・導入フロー・FAQを認識
-・CTAを構造化しています...</a:t>
-            </a:r>
-          </a:p>
-        </p:txBody>
-      </p:sp>
-      <p:sp>
-        <p:nvSpPr>
-          <p:cNvPr id="25" name="TextBox 24"/>
-          <p:cNvSpPr txBox="1"/>
-          <p:nvPr/>
-        </p:nvSpPr>
-        <p:spPr>
-          <a:xfrm>
-            <a:off x="9997440" y="3636671"/>
-            <a:ext cx="1828800" cy="137232"/>
-          </a:xfrm>
-          <a:prstGeom prst="rect">
-            <a:avLst/>
-          </a:prstGeom>
-          <a:noFill/>
-        </p:spPr>
-        <p:txBody>
-          <a:bodyPr wrap="none" lIns="0" rIns="0" tIns="0" bIns="0">
-            <a:spAutoFit/>
-          </a:bodyPr>
-          <a:lstStyle/>
-          <a:p>
-            <a:r>
-              <a:rPr b="1" sz="1000">
-                <a:solidFill>
-                  <a:srgbClr val="00E5FF"/>
-                </a:solidFill>
-                <a:latin typeface="Yu Gothic"/>
-              </a:rPr>
-              <a:t>最近のログ</a:t>
-            </a:r>
-          </a:p>
-        </p:txBody>
-      </p:sp>
-      <p:sp>
-        <p:nvSpPr>
-          <p:cNvPr id="26" name="TextBox 25"/>
-          <p:cNvSpPr txBox="1"/>
-          <p:nvPr/>
-        </p:nvSpPr>
-        <p:spPr>
-          <a:xfrm>
-            <a:off x="9997440" y="3842521"/>
-            <a:ext cx="1950720" cy="892013"/>
-          </a:xfrm>
-          <a:prstGeom prst="rect">
-            <a:avLst/>
-          </a:prstGeom>
-          <a:noFill/>
-        </p:spPr>
-        <p:txBody>
-          <a:bodyPr wrap="none" lIns="0" rIns="0" tIns="0" bIns="0">
-            <a:spAutoFit/>
-          </a:bodyPr>
-          <a:lstStyle/>
-          <a:p>
-            <a:r>
-              <a:rPr b="0" sz="800">
-                <a:solidFill>
-                  <a:srgbClr val="CCCCCC"/>
-                </a:solidFill>
-                <a:latin typeface="Meiryo"/>
-              </a:rPr>
-              <a:t>12:30:15 デザインカンプを生成しました
-12:30:42 カンプ解析を開始しました
-12:31:18 ヒーロー領域を解析しました
-12:31:46 サービスカードを抽出しました
-12:32:03 FAQセクションを認識しました
-12:32:21 CTAを構造化しています...
-12:32:58 HTML分解に移行予定</a:t>
-            </a:r>
-          </a:p>
-        </p:txBody>
-      </p:sp>
-      <p:sp>
-        <p:nvSpPr>
-          <p:cNvPr id="27" name="Rounded Rectangle 26"/>
-          <p:cNvSpPr/>
-          <p:nvPr/>
-        </p:nvSpPr>
-        <p:spPr>
-          <a:xfrm>
-            <a:off x="121920" y="4665918"/>
-            <a:ext cx="2072640" cy="274465"/>
-          </a:xfrm>
-          <a:prstGeom prst="roundRect">
-            <a:avLst/>
-          </a:prstGeom>
-          <a:solidFill>
-            <a:srgbClr val="001533"/>
-          </a:solidFill>
-          <a:ln w="15000">
-            <a:solidFill>
-              <a:srgbClr val="00E5FF"/>
-            </a:solidFill>
-          </a:ln>
-        </p:spPr>
-        <p:style>
-          <a:lnRef idx="1">
-            <a:schemeClr val="accent1"/>
-          </a:lnRef>
-          <a:fillRef idx="3">
-            <a:schemeClr val="accent1"/>
-          </a:fillRef>
-          <a:effectRef idx="2">
-            <a:schemeClr val="accent1"/>
-          </a:effectRef>
-          <a:fontRef idx="minor">
-            <a:schemeClr val="lt1"/>
-          </a:fontRef>
-        </p:style>
-        <p:txBody>
-          <a:bodyPr rtlCol="0" anchor="ctr" lIns="70000" rIns="70000" tIns="50000" bIns="50000" wrap="square"/>
-          <a:lstStyle/>
-          <a:p>
-            <a:pPr algn="ctr"/>
-            <a:r>
-              <a:rPr b="1" sz="1100">
-                <a:solidFill>
-                  <a:srgbClr val="FFFFFF"/>
-                </a:solidFill>
-                <a:latin typeface="Yu Gothic"/>
-              </a:rPr>
-              <a:t>重要キーワード</a:t>
-            </a:r>
-          </a:p>
-        </p:txBody>
-      </p:sp>
-      <p:sp>
-        <p:nvSpPr>
-          <p:cNvPr id="28" name="Rounded Rectangle 27"/>
-          <p:cNvSpPr/>
-          <p:nvPr/>
-        </p:nvSpPr>
-        <p:spPr>
-          <a:xfrm>
-            <a:off x="121920" y="5009000"/>
-            <a:ext cx="975360" cy="205849"/>
-          </a:xfrm>
-          <a:prstGeom prst="roundRect">
-            <a:avLst/>
-          </a:prstGeom>
-          <a:solidFill>
-            <a:srgbClr val="002244"/>
-          </a:solidFill>
-          <a:ln w="15000">
-            <a:solidFill>
-              <a:srgbClr val="00E5FF"/>
-            </a:solidFill>
-          </a:ln>
-        </p:spPr>
-        <p:style>
-          <a:lnRef idx="1">
-            <a:schemeClr val="accent1"/>
-          </a:lnRef>
-          <a:fillRef idx="3">
-            <a:schemeClr val="accent1"/>
-          </a:fillRef>
-          <a:effectRef idx="2">
-            <a:schemeClr val="accent1"/>
-          </a:effectRef>
-          <a:fontRef idx="minor">
-            <a:schemeClr val="lt1"/>
-          </a:fontRef>
-        </p:style>
-        <p:txBody>
-          <a:bodyPr rtlCol="0" anchor="ctr" lIns="70000" rIns="70000" tIns="50000" bIns="50000" wrap="square"/>
-          <a:lstStyle/>
-          <a:p>
-            <a:pPr algn="ctr"/>
-            <a:r>
-              <a:rPr b="1" sz="900">
-                <a:solidFill>
-                  <a:srgbClr val="FFFFFF"/>
-                </a:solidFill>
-                <a:latin typeface="Yu Gothic"/>
-              </a:rPr>
-              <a:t>個別設計</a:t>
-            </a:r>
-          </a:p>
-        </p:txBody>
-      </p:sp>
-      <p:sp>
-        <p:nvSpPr>
-          <p:cNvPr id="29" name="Rounded Rectangle 28"/>
-          <p:cNvSpPr/>
-          <p:nvPr/>
-        </p:nvSpPr>
-        <p:spPr>
-          <a:xfrm>
-            <a:off x="1219200" y="5009000"/>
-            <a:ext cx="975360" cy="205849"/>
-          </a:xfrm>
-          <a:prstGeom prst="roundRect">
-            <a:avLst/>
-          </a:prstGeom>
-          <a:solidFill>
-            <a:srgbClr val="002244"/>
-          </a:solidFill>
-          <a:ln w="15000">
-            <a:solidFill>
-              <a:srgbClr val="00E5FF"/>
-            </a:solidFill>
-          </a:ln>
-        </p:spPr>
-        <p:style>
-          <a:lnRef idx="1">
-            <a:schemeClr val="accent1"/>
-          </a:lnRef>
-          <a:fillRef idx="3">
-            <a:schemeClr val="accent1"/>
-          </a:fillRef>
-          <a:effectRef idx="2">
-            <a:schemeClr val="accent1"/>
-          </a:effectRef>
-          <a:fontRef idx="minor">
-            <a:schemeClr val="lt1"/>
-          </a:fontRef>
-        </p:style>
-        <p:txBody>
-          <a:bodyPr rtlCol="0" anchor="ctr" lIns="70000" rIns="70000" tIns="50000" bIns="50000" wrap="square"/>
-          <a:lstStyle/>
-          <a:p>
-            <a:pPr algn="ctr"/>
-            <a:r>
-              <a:rPr b="1" sz="900">
-                <a:solidFill>
-                  <a:srgbClr val="FFFFFF"/>
-                </a:solidFill>
-                <a:latin typeface="Yu Gothic"/>
-              </a:rPr>
-              <a:t>テンプレート廃止</a:t>
-            </a:r>
-          </a:p>
-        </p:txBody>
-      </p:sp>
-      <p:sp>
-        <p:nvSpPr>
-          <p:cNvPr id="30" name="Rounded Rectangle 29"/>
-          <p:cNvSpPr/>
-          <p:nvPr/>
-        </p:nvSpPr>
-        <p:spPr>
-          <a:xfrm>
-            <a:off x="121920" y="5283466"/>
-            <a:ext cx="975360" cy="205849"/>
-          </a:xfrm>
-          <a:prstGeom prst="roundRect">
-            <a:avLst/>
-          </a:prstGeom>
-          <a:solidFill>
-            <a:srgbClr val="002244"/>
-          </a:solidFill>
-          <a:ln w="15000">
-            <a:solidFill>
-              <a:srgbClr val="00E5FF"/>
-            </a:solidFill>
-          </a:ln>
-        </p:spPr>
-        <p:style>
-          <a:lnRef idx="1">
-            <a:schemeClr val="accent1"/>
-          </a:lnRef>
-          <a:fillRef idx="3">
-            <a:schemeClr val="accent1"/>
-          </a:fillRef>
-          <a:effectRef idx="2">
-            <a:schemeClr val="accent1"/>
-          </a:effectRef>
-          <a:fontRef idx="minor">
-            <a:schemeClr val="lt1"/>
-          </a:fontRef>
-        </p:style>
-        <p:txBody>
-          <a:bodyPr rtlCol="0" anchor="ctr" lIns="70000" rIns="70000" tIns="50000" bIns="50000" wrap="square"/>
-          <a:lstStyle/>
-          <a:p>
-            <a:pPr algn="ctr"/>
-            <a:r>
-              <a:rPr b="1" sz="900">
-                <a:solidFill>
-                  <a:srgbClr val="FFFFFF"/>
-                </a:solidFill>
-                <a:latin typeface="Yu Gothic"/>
-              </a:rPr>
-              <a:t>カンプ解析</a:t>
-            </a:r>
-          </a:p>
-        </p:txBody>
-      </p:sp>
-      <p:sp>
-        <p:nvSpPr>
-          <p:cNvPr id="31" name="Rounded Rectangle 30"/>
-          <p:cNvSpPr/>
-          <p:nvPr/>
-        </p:nvSpPr>
-        <p:spPr>
-          <a:xfrm>
-            <a:off x="1219200" y="5283466"/>
-            <a:ext cx="975360" cy="205849"/>
-          </a:xfrm>
-          <a:prstGeom prst="roundRect">
-            <a:avLst/>
-          </a:prstGeom>
-          <a:solidFill>
-            <a:srgbClr val="002244"/>
-          </a:solidFill>
-          <a:ln w="15000">
-            <a:solidFill>
-              <a:srgbClr val="00E5FF"/>
-            </a:solidFill>
-          </a:ln>
-        </p:spPr>
-        <p:style>
-          <a:lnRef idx="1">
-            <a:schemeClr val="accent1"/>
-          </a:lnRef>
-          <a:fillRef idx="3">
-            <a:schemeClr val="accent1"/>
-          </a:fillRef>
-          <a:effectRef idx="2">
-            <a:schemeClr val="accent1"/>
-          </a:effectRef>
-          <a:fontRef idx="minor">
-            <a:schemeClr val="lt1"/>
-          </a:fontRef>
-        </p:style>
-        <p:txBody>
-          <a:bodyPr rtlCol="0" anchor="ctr" lIns="70000" rIns="70000" tIns="50000" bIns="50000" wrap="square"/>
-          <a:lstStyle/>
-          <a:p>
-            <a:pPr algn="ctr"/>
-            <a:r>
-              <a:rPr b="1" sz="900">
-                <a:solidFill>
-                  <a:srgbClr val="FFFFFF"/>
-                </a:solidFill>
-                <a:latin typeface="Yu Gothic"/>
-              </a:rPr>
-              <a:t>HTML分解</a:t>
-            </a:r>
-          </a:p>
-        </p:txBody>
-      </p:sp>
-      <p:sp>
-        <p:nvSpPr>
-          <p:cNvPr id="32" name="Rounded Rectangle 31"/>
-          <p:cNvSpPr/>
-          <p:nvPr/>
-        </p:nvSpPr>
-        <p:spPr>
-          <a:xfrm>
-            <a:off x="121920" y="5557932"/>
-            <a:ext cx="975360" cy="205849"/>
-          </a:xfrm>
-          <a:prstGeom prst="roundRect">
-            <a:avLst/>
-          </a:prstGeom>
-          <a:solidFill>
-            <a:srgbClr val="002244"/>
-          </a:solidFill>
-          <a:ln w="15000">
-            <a:solidFill>
-              <a:srgbClr val="00E5FF"/>
-            </a:solidFill>
-          </a:ln>
-        </p:spPr>
-        <p:style>
-          <a:lnRef idx="1">
-            <a:schemeClr val="accent1"/>
-          </a:lnRef>
-          <a:fillRef idx="3">
-            <a:schemeClr val="accent1"/>
-          </a:fillRef>
-          <a:effectRef idx="2">
-            <a:schemeClr val="accent1"/>
-          </a:effectRef>
-          <a:fontRef idx="minor">
-            <a:schemeClr val="lt1"/>
-          </a:fontRef>
-        </p:style>
-        <p:txBody>
-          <a:bodyPr rtlCol="0" anchor="ctr" lIns="70000" rIns="70000" tIns="50000" bIns="50000" wrap="square"/>
-          <a:lstStyle/>
-          <a:p>
-            <a:pPr algn="ctr"/>
-            <a:r>
-              <a:rPr b="1" sz="900">
-                <a:solidFill>
-                  <a:srgbClr val="FFFFFF"/>
-                </a:solidFill>
-                <a:latin typeface="Yu Gothic"/>
-              </a:rPr>
-              <a:t>AEO対策</a:t>
-            </a:r>
-          </a:p>
-        </p:txBody>
-      </p:sp>
-      <p:sp>
-        <p:nvSpPr>
-          <p:cNvPr id="33" name="Rounded Rectangle 32"/>
-          <p:cNvSpPr/>
-          <p:nvPr/>
-        </p:nvSpPr>
-        <p:spPr>
-          <a:xfrm>
-            <a:off x="1219200" y="5557932"/>
-            <a:ext cx="975360" cy="205849"/>
-          </a:xfrm>
-          <a:prstGeom prst="roundRect">
-            <a:avLst/>
-          </a:prstGeom>
-          <a:solidFill>
-            <a:srgbClr val="002244"/>
-          </a:solidFill>
-          <a:ln w="15000">
-            <a:solidFill>
-              <a:srgbClr val="00E5FF"/>
-            </a:solidFill>
-          </a:ln>
-        </p:spPr>
-        <p:style>
-          <a:lnRef idx="1">
-            <a:schemeClr val="accent1"/>
-          </a:lnRef>
-          <a:fillRef idx="3">
-            <a:schemeClr val="accent1"/>
-          </a:fillRef>
-          <a:effectRef idx="2">
-            <a:schemeClr val="accent1"/>
-          </a:effectRef>
-          <a:fontRef idx="minor">
-            <a:schemeClr val="lt1"/>
-          </a:fontRef>
-        </p:style>
-        <p:txBody>
-          <a:bodyPr rtlCol="0" anchor="ctr" lIns="70000" rIns="70000" tIns="50000" bIns="50000" wrap="square"/>
-          <a:lstStyle/>
-          <a:p>
-            <a:pPr algn="ctr"/>
-            <a:r>
-              <a:rPr b="1" sz="900">
-                <a:solidFill>
-                  <a:srgbClr val="FFFFFF"/>
-                </a:solidFill>
-                <a:latin typeface="Yu Gothic"/>
-              </a:rPr>
-              <a:t>LLMO対策</a:t>
-            </a:r>
-          </a:p>
-        </p:txBody>
-      </p:sp>
-      <p:sp>
-        <p:nvSpPr>
-          <p:cNvPr id="34" name="Rounded Rectangle 33"/>
-          <p:cNvSpPr/>
-          <p:nvPr/>
-        </p:nvSpPr>
-        <p:spPr>
-          <a:xfrm>
-            <a:off x="121920" y="5832398"/>
-            <a:ext cx="975360" cy="205849"/>
-          </a:xfrm>
-          <a:prstGeom prst="roundRect">
-            <a:avLst/>
-          </a:prstGeom>
-          <a:solidFill>
-            <a:srgbClr val="002244"/>
-          </a:solidFill>
-          <a:ln w="15000">
-            <a:solidFill>
-              <a:srgbClr val="00E5FF"/>
-            </a:solidFill>
-          </a:ln>
-        </p:spPr>
-        <p:style>
-          <a:lnRef idx="1">
-            <a:schemeClr val="accent1"/>
-          </a:lnRef>
-          <a:fillRef idx="3">
-            <a:schemeClr val="accent1"/>
-          </a:fillRef>
-          <a:effectRef idx="2">
-            <a:schemeClr val="accent1"/>
-          </a:effectRef>
-          <a:fontRef idx="minor">
-            <a:schemeClr val="lt1"/>
-          </a:fontRef>
-        </p:style>
-        <p:txBody>
-          <a:bodyPr rtlCol="0" anchor="ctr" lIns="70000" rIns="70000" tIns="50000" bIns="50000" wrap="square"/>
-          <a:lstStyle/>
-          <a:p>
-            <a:pPr algn="ctr"/>
-            <a:r>
-              <a:rPr b="1" sz="900">
-                <a:solidFill>
-                  <a:srgbClr val="FFFFFF"/>
-                </a:solidFill>
-                <a:latin typeface="Yu Gothic"/>
-              </a:rPr>
-              <a:t>問い合わせ導線</a:t>
-            </a:r>
-          </a:p>
-        </p:txBody>
-      </p:sp>
-      <p:sp>
-        <p:nvSpPr>
-          <p:cNvPr id="35" name="Rounded Rectangle 34"/>
-          <p:cNvSpPr/>
-          <p:nvPr/>
-        </p:nvSpPr>
-        <p:spPr>
-          <a:xfrm>
-            <a:off x="1219200" y="5832398"/>
-            <a:ext cx="975360" cy="205849"/>
-          </a:xfrm>
-          <a:prstGeom prst="roundRect">
-            <a:avLst/>
-          </a:prstGeom>
-          <a:solidFill>
-            <a:srgbClr val="002244"/>
-          </a:solidFill>
-          <a:ln w="15000">
-            <a:solidFill>
-              <a:srgbClr val="00E5FF"/>
-            </a:solidFill>
-          </a:ln>
-        </p:spPr>
-        <p:style>
-          <a:lnRef idx="1">
-            <a:schemeClr val="accent1"/>
-          </a:lnRef>
-          <a:fillRef idx="3">
-            <a:schemeClr val="accent1"/>
-          </a:fillRef>
-          <a:effectRef idx="2">
-            <a:schemeClr val="accent1"/>
-          </a:effectRef>
-          <a:fontRef idx="minor">
-            <a:schemeClr val="lt1"/>
-          </a:fontRef>
-        </p:style>
-        <p:txBody>
-          <a:bodyPr rtlCol="0" anchor="ctr" lIns="70000" rIns="70000" tIns="50000" bIns="50000" wrap="square"/>
-          <a:lstStyle/>
-          <a:p>
-            <a:pPr algn="ctr"/>
-            <a:r>
-              <a:rPr b="1" sz="900">
-                <a:solidFill>
-                  <a:srgbClr val="FFFFFF"/>
-                </a:solidFill>
-                <a:latin typeface="Yu Gothic"/>
-              </a:rPr>
-              <a:t>スマホ最適化</a:t>
-            </a:r>
-          </a:p>
-        </p:txBody>
-      </p:sp>
-      <p:sp>
-        <p:nvSpPr>
-          <p:cNvPr id="36" name="Rounded Rectangle 35"/>
-          <p:cNvSpPr/>
-          <p:nvPr/>
-        </p:nvSpPr>
-        <p:spPr>
-          <a:xfrm>
-            <a:off x="121920" y="6106864"/>
-            <a:ext cx="975360" cy="205849"/>
-          </a:xfrm>
-          <a:prstGeom prst="roundRect">
-            <a:avLst/>
-          </a:prstGeom>
-          <a:solidFill>
-            <a:srgbClr val="002244"/>
-          </a:solidFill>
-          <a:ln w="15000">
-            <a:solidFill>
-              <a:srgbClr val="00E5FF"/>
-            </a:solidFill>
-          </a:ln>
-        </p:spPr>
-        <p:style>
-          <a:lnRef idx="1">
-            <a:schemeClr val="accent1"/>
-          </a:lnRef>
-          <a:fillRef idx="3">
-            <a:schemeClr val="accent1"/>
-          </a:fillRef>
-          <a:effectRef idx="2">
-            <a:schemeClr val="accent1"/>
-          </a:effectRef>
-          <a:fontRef idx="minor">
-            <a:schemeClr val="lt1"/>
-          </a:fontRef>
-        </p:style>
-        <p:txBody>
-          <a:bodyPr rtlCol="0" anchor="ctr" lIns="70000" rIns="70000" tIns="50000" bIns="50000" wrap="square"/>
-          <a:lstStyle/>
-          <a:p>
-            <a:pPr algn="ctr"/>
-            <a:r>
-              <a:rPr b="1" sz="900">
-                <a:solidFill>
-                  <a:srgbClr val="FFFFFF"/>
-                </a:solidFill>
-                <a:latin typeface="Yu Gothic"/>
-              </a:rPr>
-              <a:t>独立ページ生成</a:t>
-            </a:r>
-          </a:p>
-        </p:txBody>
-      </p:sp>
-      <p:sp>
-        <p:nvSpPr>
-          <p:cNvPr id="37" name="TextBox 36"/>
-          <p:cNvSpPr txBox="1"/>
-          <p:nvPr/>
-        </p:nvSpPr>
-        <p:spPr>
-          <a:xfrm>
-            <a:off x="11948160" y="4734535"/>
-            <a:ext cx="3048000" cy="205849"/>
-          </a:xfrm>
-          <a:prstGeom prst="rect">
-            <a:avLst/>
-          </a:prstGeom>
-          <a:noFill/>
-        </p:spPr>
-        <p:txBody>
-          <a:bodyPr wrap="none" lIns="0" rIns="0" tIns="0" bIns="0">
-            <a:spAutoFit/>
-          </a:bodyPr>
-          <a:lstStyle/>
-          <a:p>
-            <a:r>
-              <a:rPr b="1" sz="1100">
-                <a:solidFill>
-                  <a:srgbClr val="FFFFFF"/>
-                </a:solidFill>
-                <a:latin typeface="Yu Gothic"/>
-              </a:rPr>
-              <a:t>① デザインカンプ生成 (A案・B案・C案・D案)</a:t>
-            </a:r>
-          </a:p>
-        </p:txBody>
-      </p:sp>
-      <p:sp>
-        <p:nvSpPr>
-          <p:cNvPr id="38" name="TextBox 37"/>
-          <p:cNvSpPr txBox="1"/>
-          <p:nvPr/>
-        </p:nvSpPr>
-        <p:spPr>
-          <a:xfrm>
-            <a:off x="6217920" y="4734535"/>
-            <a:ext cx="1463040" cy="205849"/>
-          </a:xfrm>
-          <a:prstGeom prst="rect">
-            <a:avLst/>
-          </a:prstGeom>
-          <a:noFill/>
-        </p:spPr>
-        <p:txBody>
-          <a:bodyPr wrap="none" lIns="0" rIns="0" tIns="0" bIns="0">
-            <a:spAutoFit/>
-          </a:bodyPr>
-          <a:lstStyle/>
-          <a:p>
-            <a:r>
-              <a:rPr b="1" sz="1100">
-                <a:solidFill>
-                  <a:srgbClr val="FFFFFF"/>
-                </a:solidFill>
-                <a:latin typeface="Yu Gothic"/>
-              </a:rPr>
-              <a:t>② カンプ解析</a:t>
-            </a:r>
-          </a:p>
-        </p:txBody>
-      </p:sp>
-      <p:sp>
-        <p:nvSpPr>
-          <p:cNvPr id="39" name="TextBox 38"/>
-          <p:cNvSpPr txBox="1"/>
-          <p:nvPr/>
-        </p:nvSpPr>
-        <p:spPr>
-          <a:xfrm>
-            <a:off x="8168640" y="4734535"/>
-            <a:ext cx="1463040" cy="205849"/>
-          </a:xfrm>
-          <a:prstGeom prst="rect">
-            <a:avLst/>
-          </a:prstGeom>
-          <a:noFill/>
-        </p:spPr>
-        <p:txBody>
-          <a:bodyPr wrap="none" lIns="0" rIns="0" tIns="0" bIns="0">
-            <a:spAutoFit/>
-          </a:bodyPr>
-          <a:lstStyle/>
-          <a:p>
-            <a:r>
-              <a:rPr b="1" sz="1100">
-                <a:solidFill>
-                  <a:srgbClr val="FFFFFF"/>
-                </a:solidFill>
-                <a:latin typeface="Yu Gothic"/>
-              </a:rPr>
-              <a:t>③ HTML分解</a:t>
-            </a:r>
-          </a:p>
-        </p:txBody>
-      </p:sp>
-      <p:sp>
-        <p:nvSpPr>
-          <p:cNvPr id="40" name="TextBox 39"/>
-          <p:cNvSpPr txBox="1"/>
-          <p:nvPr/>
-        </p:nvSpPr>
-        <p:spPr>
-          <a:xfrm>
-            <a:off x="10119360" y="4803151"/>
-            <a:ext cx="1463040" cy="205849"/>
-          </a:xfrm>
-          <a:prstGeom prst="rect">
-            <a:avLst/>
-          </a:prstGeom>
-          <a:noFill/>
-        </p:spPr>
-        <p:txBody>
-          <a:bodyPr wrap="none" lIns="0" rIns="0" tIns="0" bIns="0">
-            <a:spAutoFit/>
-          </a:bodyPr>
-          <a:lstStyle/>
-          <a:p>
-            <a:r>
-              <a:rPr b="1" sz="1100">
-                <a:solidFill>
-                  <a:srgbClr val="FFFFFF"/>
-                </a:solidFill>
-                <a:latin typeface="Yu Gothic"/>
-              </a:rPr>
-              <a:t>④ 個別LP完成</a:t>
-            </a:r>
-          </a:p>
-        </p:txBody>
-      </p:sp>
-      <p:sp>
-        <p:nvSpPr>
-          <p:cNvPr id="41" name="TextBox 40"/>
-          <p:cNvSpPr txBox="1"/>
-          <p:nvPr/>
-        </p:nvSpPr>
-        <p:spPr>
-          <a:xfrm>
-            <a:off x="1097280" y="6518562"/>
-            <a:ext cx="9997440" cy="274465"/>
-          </a:xfrm>
-          <a:prstGeom prst="rect">
-            <a:avLst/>
-          </a:prstGeom>
-          <a:noFill/>
-        </p:spPr>
-        <p:txBody>
-          <a:bodyPr wrap="none" lIns="0" rIns="0" tIns="0" bIns="0">
-            <a:spAutoFit/>
-          </a:bodyPr>
-          <a:lstStyle/>
-          <a:p>
-            <a:r>
-              <a:rPr b="1" sz="1300">
-                <a:solidFill>
-                  <a:srgbClr val="FFFFFF"/>
-                </a:solidFill>
-                <a:latin typeface="Yu Gothic"/>
-              </a:rPr>
-              <a:t>画像を貼るだけではありません。意味を理解し、HTMLとして再構築することで、御社専用の“本物のLP”を生成します。</a:t>
+              <a:t>ご相談・お見積りは無料です</a:t>
             </a:r>
           </a:p>
         </p:txBody>
       </p:sp>
       <p:pic>
         <p:nvPicPr>
-          <p:cNvPr id="42" name="Picture 41" descr="region-0.png"/>
-          <p:cNvPicPr>
-            <a:picLocks noChangeAspect="1"/>
-          </p:cNvPicPr>
-          <p:nvPr/>
-        </p:nvPicPr>
-        <p:blipFill>
-          <a:blip r:embed="rId2"/>
-          <a:stretch>
-            <a:fillRect/>
-          </a:stretch>
-        </p:blipFill>
-        <p:spPr>
-          <a:xfrm>
-            <a:off x="3779520" y="1921260"/>
-            <a:ext cx="3901440" cy="1646794"/>
-          </a:xfrm>
-          <a:prstGeom prst="rect">
-            <a:avLst/>
-          </a:prstGeom>
-        </p:spPr>
-      </p:pic>
-      <p:pic>
-        <p:nvPicPr>
-          <p:cNvPr id="43" name="Picture 42" descr="region-1.png"/>
-          <p:cNvPicPr>
-            <a:picLocks noChangeAspect="1"/>
-          </p:cNvPicPr>
-          <p:nvPr/>
-        </p:nvPicPr>
-        <p:blipFill>
-          <a:blip r:embed="rId3"/>
-          <a:stretch>
-            <a:fillRect/>
-          </a:stretch>
-        </p:blipFill>
-        <p:spPr>
-          <a:xfrm>
-            <a:off x="2316480" y="4940384"/>
-            <a:ext cx="3413760" cy="1372329"/>
-          </a:xfrm>
-          <a:prstGeom prst="rect">
-            <a:avLst/>
-          </a:prstGeom>
-        </p:spPr>
-      </p:pic>
-      <p:pic>
-        <p:nvPicPr>
-          <p:cNvPr id="44" name="Picture 43" descr="region-2.png"/>
+          <p:cNvPr id="54" name="Picture 53" descr="region-0.png"/>
           <p:cNvPicPr>
             <a:picLocks noChangeAspect="1"/>
           </p:cNvPicPr>
@@ -5141,8 +5010,8 @@
         </p:blipFill>
         <p:spPr>
           <a:xfrm>
-            <a:off x="5974080" y="4940384"/>
-            <a:ext cx="1828800" cy="1372329"/>
+            <a:off x="3738880" y="243840"/>
+            <a:ext cx="4226560" cy="4267200"/>
           </a:xfrm>
           <a:prstGeom prst="rect">
             <a:avLst/>
@@ -5151,7 +5020,7 @@
       </p:pic>
       <p:pic>
         <p:nvPicPr>
-          <p:cNvPr id="45" name="Picture 44" descr="region-3.png"/>
+          <p:cNvPr id="55" name="Picture 54" descr="region-2.png"/>
           <p:cNvPicPr>
             <a:picLocks noChangeAspect="1"/>
           </p:cNvPicPr>
@@ -5165,8 +5034,8 @@
         </p:blipFill>
         <p:spPr>
           <a:xfrm>
-            <a:off x="8046720" y="4940384"/>
-            <a:ext cx="1584960" cy="1372329"/>
+            <a:off x="243840" y="8412480"/>
+            <a:ext cx="1463040" cy="1341120"/>
           </a:xfrm>
           <a:prstGeom prst="rect">
             <a:avLst/>
@@ -5175,7 +5044,7 @@
       </p:pic>
       <p:pic>
         <p:nvPicPr>
-          <p:cNvPr id="46" name="Picture 45" descr="region-4.png"/>
+          <p:cNvPr id="56" name="Picture 55" descr="region-3.png"/>
           <p:cNvPicPr>
             <a:picLocks noChangeAspect="1"/>
           </p:cNvPicPr>
@@ -5189,8 +5058,8 @@
         </p:blipFill>
         <p:spPr>
           <a:xfrm>
-            <a:off x="9631680" y="5009000"/>
-            <a:ext cx="2438400" cy="1440945"/>
+            <a:off x="6177280" y="8412480"/>
+            <a:ext cx="1544320" cy="1341120"/>
           </a:xfrm>
           <a:prstGeom prst="rect">
             <a:avLst/>

</xml_diff>